<commit_message>
Amili Semai Mubteda Nasb Haber Ref Added
</commit_message>
<xml_diff>
--- a/Nahiv/Avamil/Amil.pptx
+++ b/Nahiv/Avamil/Amil.pptx
@@ -124,7 +124,7 @@
   <pc:docChgLst>
     <pc:chgData name="Ayhan Karaman" userId="ec277a7f08761a62" providerId="LiveId" clId="{A7318BDB-BC3B-435E-9587-295F14AD73EF}"/>
     <pc:docChg chg="undo redo custSel addSld modSld">
-      <pc:chgData name="Ayhan Karaman" userId="ec277a7f08761a62" providerId="LiveId" clId="{A7318BDB-BC3B-435E-9587-295F14AD73EF}" dt="2026-10-12T18:36:10.923" v="4523" actId="115"/>
+      <pc:chgData name="Ayhan Karaman" userId="ec277a7f08761a62" providerId="LiveId" clId="{A7318BDB-BC3B-435E-9587-295F14AD73EF}" dt="2026-10-13T20:23:03.563" v="5932" actId="207"/>
       <pc:docMkLst>
         <pc:docMk/>
       </pc:docMkLst>
@@ -838,7 +838,7 @@
         </pc:graphicFrameChg>
       </pc:sldChg>
       <pc:sldChg chg="addSp delSp modSp add mod">
-        <pc:chgData name="Ayhan Karaman" userId="ec277a7f08761a62" providerId="LiveId" clId="{A7318BDB-BC3B-435E-9587-295F14AD73EF}" dt="2026-10-12T18:36:10.923" v="4523" actId="115"/>
+        <pc:chgData name="Ayhan Karaman" userId="ec277a7f08761a62" providerId="LiveId" clId="{A7318BDB-BC3B-435E-9587-295F14AD73EF}" dt="2026-10-13T20:23:03.563" v="5932" actId="207"/>
         <pc:sldMkLst>
           <pc:docMk/>
           <pc:sldMk cId="2335362230" sldId="259"/>
@@ -867,6 +867,78 @@
             <ac:spMk id="5" creationId="{D158510D-C4F3-24F0-5171-960FD2A8E88A}"/>
           </ac:spMkLst>
         </pc:spChg>
+        <pc:spChg chg="add mod">
+          <ac:chgData name="Ayhan Karaman" userId="ec277a7f08761a62" providerId="LiveId" clId="{A7318BDB-BC3B-435E-9587-295F14AD73EF}" dt="2026-10-13T19:40:58.711" v="4762" actId="164"/>
+          <ac:spMkLst>
+            <pc:docMk/>
+            <pc:sldMk cId="2335362230" sldId="259"/>
+            <ac:spMk id="6" creationId="{7D2E4C20-0447-30E0-F29F-D327E050685C}"/>
+          </ac:spMkLst>
+        </pc:spChg>
+        <pc:spChg chg="add mod">
+          <ac:chgData name="Ayhan Karaman" userId="ec277a7f08761a62" providerId="LiveId" clId="{A7318BDB-BC3B-435E-9587-295F14AD73EF}" dt="2026-10-13T19:40:58.711" v="4762" actId="164"/>
+          <ac:spMkLst>
+            <pc:docMk/>
+            <pc:sldMk cId="2335362230" sldId="259"/>
+            <ac:spMk id="18" creationId="{AAEF7D8B-3751-A359-3592-43BB2EEDE25A}"/>
+          </ac:spMkLst>
+        </pc:spChg>
+        <pc:spChg chg="add mod">
+          <ac:chgData name="Ayhan Karaman" userId="ec277a7f08761a62" providerId="LiveId" clId="{A7318BDB-BC3B-435E-9587-295F14AD73EF}" dt="2026-10-13T19:40:58.711" v="4762" actId="164"/>
+          <ac:spMkLst>
+            <pc:docMk/>
+            <pc:sldMk cId="2335362230" sldId="259"/>
+            <ac:spMk id="19" creationId="{3A52134C-2DF9-E525-0458-CA2866B3D0B4}"/>
+          </ac:spMkLst>
+        </pc:spChg>
+        <pc:spChg chg="add mod">
+          <ac:chgData name="Ayhan Karaman" userId="ec277a7f08761a62" providerId="LiveId" clId="{A7318BDB-BC3B-435E-9587-295F14AD73EF}" dt="2026-10-13T19:40:58.711" v="4762" actId="164"/>
+          <ac:spMkLst>
+            <pc:docMk/>
+            <pc:sldMk cId="2335362230" sldId="259"/>
+            <ac:spMk id="21" creationId="{4DB9819B-6F8F-25E8-EA01-12F8FC009ACF}"/>
+          </ac:spMkLst>
+        </pc:spChg>
+        <pc:spChg chg="add mod">
+          <ac:chgData name="Ayhan Karaman" userId="ec277a7f08761a62" providerId="LiveId" clId="{A7318BDB-BC3B-435E-9587-295F14AD73EF}" dt="2026-10-13T19:40:58.711" v="4762" actId="164"/>
+          <ac:spMkLst>
+            <pc:docMk/>
+            <pc:sldMk cId="2335362230" sldId="259"/>
+            <ac:spMk id="23" creationId="{6A0DFB13-2457-0871-2E76-D73848627200}"/>
+          </ac:spMkLst>
+        </pc:spChg>
+        <pc:spChg chg="add mod">
+          <ac:chgData name="Ayhan Karaman" userId="ec277a7f08761a62" providerId="LiveId" clId="{A7318BDB-BC3B-435E-9587-295F14AD73EF}" dt="2026-10-13T19:40:58.711" v="4762" actId="164"/>
+          <ac:spMkLst>
+            <pc:docMk/>
+            <pc:sldMk cId="2335362230" sldId="259"/>
+            <ac:spMk id="24" creationId="{8FAB844F-4D13-E1EA-A687-13F47F27F642}"/>
+          </ac:spMkLst>
+        </pc:spChg>
+        <pc:spChg chg="add del mod">
+          <ac:chgData name="Ayhan Karaman" userId="ec277a7f08761a62" providerId="LiveId" clId="{A7318BDB-BC3B-435E-9587-295F14AD73EF}" dt="2026-10-13T19:40:29.803" v="4758" actId="478"/>
+          <ac:spMkLst>
+            <pc:docMk/>
+            <pc:sldMk cId="2335362230" sldId="259"/>
+            <ac:spMk id="25" creationId="{E9C27C40-AA62-37E5-8E8E-9E5A79167D02}"/>
+          </ac:spMkLst>
+        </pc:spChg>
+        <pc:grpChg chg="add mod">
+          <ac:chgData name="Ayhan Karaman" userId="ec277a7f08761a62" providerId="LiveId" clId="{A7318BDB-BC3B-435E-9587-295F14AD73EF}" dt="2026-10-13T19:41:28.664" v="4765" actId="1076"/>
+          <ac:grpSpMkLst>
+            <pc:docMk/>
+            <pc:sldMk cId="2335362230" sldId="259"/>
+            <ac:grpSpMk id="26" creationId="{C710EE87-673A-5270-A032-BCB969695A0A}"/>
+          </ac:grpSpMkLst>
+        </pc:grpChg>
+        <pc:graphicFrameChg chg="add mod modGraphic">
+          <ac:chgData name="Ayhan Karaman" userId="ec277a7f08761a62" providerId="LiveId" clId="{A7318BDB-BC3B-435E-9587-295F14AD73EF}" dt="2026-10-13T20:23:03.563" v="5932" actId="207"/>
+          <ac:graphicFrameMkLst>
+            <pc:docMk/>
+            <pc:sldMk cId="2335362230" sldId="259"/>
+            <ac:graphicFrameMk id="5" creationId="{EF0AB340-BD1A-30F4-C1A2-8B28285BD2A8}"/>
+          </ac:graphicFrameMkLst>
+        </pc:graphicFrameChg>
         <pc:graphicFrameChg chg="del">
           <ac:chgData name="Ayhan Karaman" userId="ec277a7f08761a62" providerId="LiveId" clId="{A7318BDB-BC3B-435E-9587-295F14AD73EF}" dt="2026-10-12T18:28:29.326" v="4420" actId="478"/>
           <ac:graphicFrameMkLst>
@@ -883,6 +955,62 @@
             <ac:graphicFrameMk id="9" creationId="{A9FEB907-20A7-2D65-95C7-F8C5370DE7F9}"/>
           </ac:graphicFrameMkLst>
         </pc:graphicFrameChg>
+        <pc:cxnChg chg="add del mod">
+          <ac:chgData name="Ayhan Karaman" userId="ec277a7f08761a62" providerId="LiveId" clId="{A7318BDB-BC3B-435E-9587-295F14AD73EF}" dt="2026-10-13T19:30:30.547" v="4681" actId="478"/>
+          <ac:cxnSpMkLst>
+            <pc:docMk/>
+            <pc:sldMk cId="2335362230" sldId="259"/>
+            <ac:cxnSpMk id="8" creationId="{DAFDC77C-5583-E233-A857-F5CF60F21A7C}"/>
+          </ac:cxnSpMkLst>
+        </pc:cxnChg>
+        <pc:cxnChg chg="add mod">
+          <ac:chgData name="Ayhan Karaman" userId="ec277a7f08761a62" providerId="LiveId" clId="{A7318BDB-BC3B-435E-9587-295F14AD73EF}" dt="2026-10-13T19:40:58.711" v="4762" actId="164"/>
+          <ac:cxnSpMkLst>
+            <pc:docMk/>
+            <pc:sldMk cId="2335362230" sldId="259"/>
+            <ac:cxnSpMk id="10" creationId="{54B335BC-75BE-B895-AA95-8A0C7D1A9158}"/>
+          </ac:cxnSpMkLst>
+        </pc:cxnChg>
+        <pc:cxnChg chg="add mod">
+          <ac:chgData name="Ayhan Karaman" userId="ec277a7f08761a62" providerId="LiveId" clId="{A7318BDB-BC3B-435E-9587-295F14AD73EF}" dt="2026-10-13T19:40:58.711" v="4762" actId="164"/>
+          <ac:cxnSpMkLst>
+            <pc:docMk/>
+            <pc:sldMk cId="2335362230" sldId="259"/>
+            <ac:cxnSpMk id="13" creationId="{34F3F4C2-B117-D13B-74F8-078083DF1478}"/>
+          </ac:cxnSpMkLst>
+        </pc:cxnChg>
+        <pc:cxnChg chg="add mod">
+          <ac:chgData name="Ayhan Karaman" userId="ec277a7f08761a62" providerId="LiveId" clId="{A7318BDB-BC3B-435E-9587-295F14AD73EF}" dt="2026-10-13T19:40:58.711" v="4762" actId="164"/>
+          <ac:cxnSpMkLst>
+            <pc:docMk/>
+            <pc:sldMk cId="2335362230" sldId="259"/>
+            <ac:cxnSpMk id="14" creationId="{EA7D8A47-4B37-E726-3821-AE46DCF8E07A}"/>
+          </ac:cxnSpMkLst>
+        </pc:cxnChg>
+        <pc:cxnChg chg="add mod">
+          <ac:chgData name="Ayhan Karaman" userId="ec277a7f08761a62" providerId="LiveId" clId="{A7318BDB-BC3B-435E-9587-295F14AD73EF}" dt="2026-10-13T19:40:58.711" v="4762" actId="164"/>
+          <ac:cxnSpMkLst>
+            <pc:docMk/>
+            <pc:sldMk cId="2335362230" sldId="259"/>
+            <ac:cxnSpMk id="16" creationId="{4914C597-8D81-E8AB-1541-9A985D6B3C17}"/>
+          </ac:cxnSpMkLst>
+        </pc:cxnChg>
+        <pc:cxnChg chg="add mod">
+          <ac:chgData name="Ayhan Karaman" userId="ec277a7f08761a62" providerId="LiveId" clId="{A7318BDB-BC3B-435E-9587-295F14AD73EF}" dt="2026-10-13T19:40:58.711" v="4762" actId="164"/>
+          <ac:cxnSpMkLst>
+            <pc:docMk/>
+            <pc:sldMk cId="2335362230" sldId="259"/>
+            <ac:cxnSpMk id="20" creationId="{7120F408-8A67-1554-9455-83827E9F4530}"/>
+          </ac:cxnSpMkLst>
+        </pc:cxnChg>
+        <pc:cxnChg chg="add mod">
+          <ac:chgData name="Ayhan Karaman" userId="ec277a7f08761a62" providerId="LiveId" clId="{A7318BDB-BC3B-435E-9587-295F14AD73EF}" dt="2026-10-13T19:40:58.711" v="4762" actId="164"/>
+          <ac:cxnSpMkLst>
+            <pc:docMk/>
+            <pc:sldMk cId="2335362230" sldId="259"/>
+            <ac:cxnSpMk id="22" creationId="{5DC911A5-27EB-C920-4711-36CEE11BE77B}"/>
+          </ac:cxnSpMkLst>
+        </pc:cxnChg>
       </pc:sldChg>
       <pc:sldChg chg="modSp add mod">
         <pc:chgData name="Ayhan Karaman" userId="ec277a7f08761a62" providerId="LiveId" clId="{A7318BDB-BC3B-435E-9587-295F14AD73EF}" dt="2026-10-12T18:29:25.697" v="4475" actId="20577"/>
@@ -986,7 +1114,7 @@
           <a:p>
             <a:fld id="{FA2DF9BE-F4DC-4902-9C94-926DFEDD4A7A}" type="datetimeFigureOut">
               <a:rPr lang="tr-TR" smtClean="0"/>
-              <a:t>12.10.2026</a:t>
+              <a:t>13.10.2026</a:t>
             </a:fld>
             <a:endParaRPr lang="tr-TR"/>
           </a:p>
@@ -1652,7 +1780,7 @@
           <a:p>
             <a:fld id="{47B4E739-70D6-40BD-B9BF-46BF9FC7432A}" type="datetimeFigureOut">
               <a:rPr lang="tr-TR" smtClean="0"/>
-              <a:t>12.10.2026</a:t>
+              <a:t>13.10.2026</a:t>
             </a:fld>
             <a:endParaRPr lang="tr-TR"/>
           </a:p>
@@ -1850,7 +1978,7 @@
           <a:p>
             <a:fld id="{47B4E739-70D6-40BD-B9BF-46BF9FC7432A}" type="datetimeFigureOut">
               <a:rPr lang="tr-TR" smtClean="0"/>
-              <a:t>12.10.2026</a:t>
+              <a:t>13.10.2026</a:t>
             </a:fld>
             <a:endParaRPr lang="tr-TR"/>
           </a:p>
@@ -2058,7 +2186,7 @@
           <a:p>
             <a:fld id="{47B4E739-70D6-40BD-B9BF-46BF9FC7432A}" type="datetimeFigureOut">
               <a:rPr lang="tr-TR" smtClean="0"/>
-              <a:t>12.10.2026</a:t>
+              <a:t>13.10.2026</a:t>
             </a:fld>
             <a:endParaRPr lang="tr-TR"/>
           </a:p>
@@ -2256,7 +2384,7 @@
           <a:p>
             <a:fld id="{47B4E739-70D6-40BD-B9BF-46BF9FC7432A}" type="datetimeFigureOut">
               <a:rPr lang="tr-TR" smtClean="0"/>
-              <a:t>12.10.2026</a:t>
+              <a:t>13.10.2026</a:t>
             </a:fld>
             <a:endParaRPr lang="tr-TR"/>
           </a:p>
@@ -2531,7 +2659,7 @@
           <a:p>
             <a:fld id="{47B4E739-70D6-40BD-B9BF-46BF9FC7432A}" type="datetimeFigureOut">
               <a:rPr lang="tr-TR" smtClean="0"/>
-              <a:t>12.10.2026</a:t>
+              <a:t>13.10.2026</a:t>
             </a:fld>
             <a:endParaRPr lang="tr-TR"/>
           </a:p>
@@ -2796,7 +2924,7 @@
           <a:p>
             <a:fld id="{47B4E739-70D6-40BD-B9BF-46BF9FC7432A}" type="datetimeFigureOut">
               <a:rPr lang="tr-TR" smtClean="0"/>
-              <a:t>12.10.2026</a:t>
+              <a:t>13.10.2026</a:t>
             </a:fld>
             <a:endParaRPr lang="tr-TR"/>
           </a:p>
@@ -3208,7 +3336,7 @@
           <a:p>
             <a:fld id="{47B4E739-70D6-40BD-B9BF-46BF9FC7432A}" type="datetimeFigureOut">
               <a:rPr lang="tr-TR" smtClean="0"/>
-              <a:t>12.10.2026</a:t>
+              <a:t>13.10.2026</a:t>
             </a:fld>
             <a:endParaRPr lang="tr-TR"/>
           </a:p>
@@ -3349,7 +3477,7 @@
           <a:p>
             <a:fld id="{47B4E739-70D6-40BD-B9BF-46BF9FC7432A}" type="datetimeFigureOut">
               <a:rPr lang="tr-TR" smtClean="0"/>
-              <a:t>12.10.2026</a:t>
+              <a:t>13.10.2026</a:t>
             </a:fld>
             <a:endParaRPr lang="tr-TR"/>
           </a:p>
@@ -3462,7 +3590,7 @@
           <a:p>
             <a:fld id="{47B4E739-70D6-40BD-B9BF-46BF9FC7432A}" type="datetimeFigureOut">
               <a:rPr lang="tr-TR" smtClean="0"/>
-              <a:t>12.10.2026</a:t>
+              <a:t>13.10.2026</a:t>
             </a:fld>
             <a:endParaRPr lang="tr-TR"/>
           </a:p>
@@ -3773,7 +3901,7 @@
           <a:p>
             <a:fld id="{47B4E739-70D6-40BD-B9BF-46BF9FC7432A}" type="datetimeFigureOut">
               <a:rPr lang="tr-TR" smtClean="0"/>
-              <a:t>12.10.2026</a:t>
+              <a:t>13.10.2026</a:t>
             </a:fld>
             <a:endParaRPr lang="tr-TR"/>
           </a:p>
@@ -4061,7 +4189,7 @@
           <a:p>
             <a:fld id="{47B4E739-70D6-40BD-B9BF-46BF9FC7432A}" type="datetimeFigureOut">
               <a:rPr lang="tr-TR" smtClean="0"/>
-              <a:t>12.10.2026</a:t>
+              <a:t>13.10.2026</a:t>
             </a:fld>
             <a:endParaRPr lang="tr-TR"/>
           </a:p>
@@ -4302,7 +4430,7 @@
           <a:p>
             <a:fld id="{47B4E739-70D6-40BD-B9BF-46BF9FC7432A}" type="datetimeFigureOut">
               <a:rPr lang="tr-TR" smtClean="0"/>
-              <a:t>12.10.2026</a:t>
+              <a:t>13.10.2026</a:t>
             </a:fld>
             <a:endParaRPr lang="tr-TR"/>
           </a:p>
@@ -9944,6 +10072,1876 @@
           </a:p>
         </p:txBody>
       </p:sp>
+      <p:graphicFrame>
+        <p:nvGraphicFramePr>
+          <p:cNvPr id="5" name="Tablo 4">
+            <a:extLst>
+              <a:ext uri="{FF2B5EF4-FFF2-40B4-BE49-F238E27FC236}">
+                <a16:creationId xmlns:a16="http://schemas.microsoft.com/office/drawing/2014/main" id="{EF0AB340-BD1A-30F4-C1A2-8B28285BD2A8}"/>
+              </a:ext>
+            </a:extLst>
+          </p:cNvPr>
+          <p:cNvGraphicFramePr>
+            <a:graphicFrameLocks noGrp="1"/>
+          </p:cNvGraphicFramePr>
+          <p:nvPr>
+            <p:extLst>
+              <p:ext uri="{D42A27DB-BD31-4B8C-83A1-F6EECF244321}">
+                <p14:modId xmlns:p14="http://schemas.microsoft.com/office/powerpoint/2010/main" val="2471447212"/>
+              </p:ext>
+            </p:extLst>
+          </p:nvPr>
+        </p:nvGraphicFramePr>
+        <p:xfrm>
+          <a:off x="59267" y="667258"/>
+          <a:ext cx="12073464" cy="4311147"/>
+        </p:xfrm>
+        <a:graphic>
+          <a:graphicData uri="http://schemas.openxmlformats.org/drawingml/2006/table">
+            <a:tbl>
+              <a:tblPr firstRow="1" bandRow="1">
+                <a:tableStyleId>{5C22544A-7EE6-4342-B048-85BDC9FD1C3A}</a:tableStyleId>
+              </a:tblPr>
+              <a:tblGrid>
+                <a:gridCol w="1247019">
+                  <a:extLst>
+                    <a:ext uri="{9D8B030D-6E8A-4147-A177-3AD203B41FA5}">
+                      <a16:colId xmlns:a16="http://schemas.microsoft.com/office/drawing/2014/main" val="3242288309"/>
+                    </a:ext>
+                  </a:extLst>
+                </a:gridCol>
+                <a:gridCol w="1750423">
+                  <a:extLst>
+                    <a:ext uri="{9D8B030D-6E8A-4147-A177-3AD203B41FA5}">
+                      <a16:colId xmlns:a16="http://schemas.microsoft.com/office/drawing/2014/main" val="2112445330"/>
+                    </a:ext>
+                  </a:extLst>
+                </a:gridCol>
+                <a:gridCol w="9076022">
+                  <a:extLst>
+                    <a:ext uri="{9D8B030D-6E8A-4147-A177-3AD203B41FA5}">
+                      <a16:colId xmlns:a16="http://schemas.microsoft.com/office/drawing/2014/main" val="317297140"/>
+                    </a:ext>
+                  </a:extLst>
+                </a:gridCol>
+              </a:tblGrid>
+              <a:tr h="629067">
+                <a:tc>
+                  <a:txBody>
+                    <a:bodyPr/>
+                    <a:lstStyle/>
+                    <a:p>
+                      <a:r>
+                        <a:rPr lang="tr-TR" dirty="0"/>
+                        <a:t>Harf-i Cer</a:t>
+                      </a:r>
+                    </a:p>
+                  </a:txBody>
+                  <a:tcPr/>
+                </a:tc>
+                <a:tc>
+                  <a:txBody>
+                    <a:bodyPr/>
+                    <a:lstStyle/>
+                    <a:p>
+                      <a:r>
+                        <a:rPr lang="tr-TR" dirty="0"/>
+                        <a:t>Mana</a:t>
+                      </a:r>
+                    </a:p>
+                  </a:txBody>
+                  <a:tcPr/>
+                </a:tc>
+                <a:tc>
+                  <a:txBody>
+                    <a:bodyPr/>
+                    <a:lstStyle/>
+                    <a:p>
+                      <a:r>
+                        <a:rPr lang="tr-TR" dirty="0"/>
+                        <a:t>Misal</a:t>
+                      </a:r>
+                    </a:p>
+                  </a:txBody>
+                  <a:tcPr/>
+                </a:tc>
+                <a:extLst>
+                  <a:ext uri="{0D108BD9-81ED-4DB2-BD59-A6C34878D82A}">
+                    <a16:rowId xmlns:a16="http://schemas.microsoft.com/office/drawing/2014/main" val="3289731430"/>
+                  </a:ext>
+                </a:extLst>
+              </a:tr>
+              <a:tr h="449333">
+                <a:tc>
+                  <a:txBody>
+                    <a:bodyPr/>
+                    <a:lstStyle/>
+                    <a:p>
+                      <a:pPr algn="ctr"/>
+                      <a:r>
+                        <a:rPr lang="ar-AE" sz="2400" b="1" dirty="0">
+                          <a:solidFill>
+                            <a:srgbClr val="C00000"/>
+                          </a:solidFill>
+                          <a:latin typeface="Algerian" panose="04020705040A02060702" pitchFamily="82" charset="0"/>
+                        </a:rPr>
+                        <a:t>إِنَّ</a:t>
+                      </a:r>
+                      <a:endParaRPr lang="tr-TR" sz="2400" b="1" dirty="0">
+                        <a:solidFill>
+                          <a:srgbClr val="C00000"/>
+                        </a:solidFill>
+                        <a:latin typeface="Algerian" panose="04020705040A02060702" pitchFamily="82" charset="0"/>
+                      </a:endParaRPr>
+                    </a:p>
+                  </a:txBody>
+                  <a:tcPr/>
+                </a:tc>
+                <a:tc>
+                  <a:txBody>
+                    <a:bodyPr/>
+                    <a:lstStyle/>
+                    <a:p>
+                      <a:pPr algn="ctr"/>
+                      <a:r>
+                        <a:rPr lang="tr-TR" sz="1800" dirty="0"/>
+                        <a:t>Muhakkak Ki </a:t>
+                      </a:r>
+                    </a:p>
+                  </a:txBody>
+                  <a:tcPr/>
+                </a:tc>
+                <a:tc>
+                  <a:txBody>
+                    <a:bodyPr/>
+                    <a:lstStyle/>
+                    <a:p>
+                      <a:pPr algn="ctr"/>
+                      <a:r>
+                        <a:rPr lang="ar-AE" sz="1600" b="1" kern="1200" dirty="0">
+                          <a:solidFill>
+                            <a:srgbClr val="FF0000"/>
+                          </a:solidFill>
+                          <a:latin typeface="Arabic Typesetting" panose="03020402040406030203" pitchFamily="66" charset="-78"/>
+                          <a:ea typeface="Amiri" panose="00000500000000000000" pitchFamily="2" charset="-78"/>
+                          <a:cs typeface="Arabic Typesetting" panose="03020402040406030203" pitchFamily="66" charset="-78"/>
+                        </a:rPr>
+                        <a:t>إِنَّ</a:t>
+                      </a:r>
+                      <a:r>
+                        <a:rPr lang="ar-AE" sz="1600" b="1" kern="1200" dirty="0">
+                          <a:solidFill>
+                            <a:schemeClr val="tx1"/>
+                          </a:solidFill>
+                          <a:latin typeface="Arabic Typesetting" panose="03020402040406030203" pitchFamily="66" charset="-78"/>
+                          <a:ea typeface="Amiri" panose="00000500000000000000" pitchFamily="2" charset="-78"/>
+                          <a:cs typeface="Arabic Typesetting" panose="03020402040406030203" pitchFamily="66" charset="-78"/>
+                        </a:rPr>
+                        <a:t> </a:t>
+                      </a:r>
+                      <a:r>
+                        <a:rPr lang="ar-AE" sz="1600" b="1" kern="1200" dirty="0">
+                          <a:solidFill>
+                            <a:srgbClr val="0000CC"/>
+                          </a:solidFill>
+                          <a:latin typeface="Arabic Typesetting" panose="03020402040406030203" pitchFamily="66" charset="-78"/>
+                          <a:ea typeface="Amiri" panose="00000500000000000000" pitchFamily="2" charset="-78"/>
+                          <a:cs typeface="Arabic Typesetting" panose="03020402040406030203" pitchFamily="66" charset="-78"/>
+                        </a:rPr>
+                        <a:t>اللَّهَ</a:t>
+                      </a:r>
+                      <a:r>
+                        <a:rPr lang="ar-AE" sz="1600" b="1" kern="1200" dirty="0">
+                          <a:solidFill>
+                            <a:schemeClr val="tx1"/>
+                          </a:solidFill>
+                          <a:latin typeface="Arabic Typesetting" panose="03020402040406030203" pitchFamily="66" charset="-78"/>
+                          <a:ea typeface="Amiri" panose="00000500000000000000" pitchFamily="2" charset="-78"/>
+                          <a:cs typeface="Arabic Typesetting" panose="03020402040406030203" pitchFamily="66" charset="-78"/>
+                        </a:rPr>
+                        <a:t> تَعَالَى </a:t>
+                      </a:r>
+                      <a:r>
+                        <a:rPr lang="ar-AE" sz="1600" b="1" kern="1200" dirty="0">
+                          <a:solidFill>
+                            <a:schemeClr val="accent6">
+                              <a:lumMod val="50000"/>
+                            </a:schemeClr>
+                          </a:solidFill>
+                          <a:latin typeface="Arabic Typesetting" panose="03020402040406030203" pitchFamily="66" charset="-78"/>
+                          <a:ea typeface="Amiri" panose="00000500000000000000" pitchFamily="2" charset="-78"/>
+                          <a:cs typeface="Arabic Typesetting" panose="03020402040406030203" pitchFamily="66" charset="-78"/>
+                        </a:rPr>
+                        <a:t>عَالِمُ </a:t>
+                      </a:r>
+                      <a:r>
+                        <a:rPr lang="ar-AE" sz="1600" b="1" kern="1200" dirty="0">
+                          <a:solidFill>
+                            <a:schemeClr val="tx1"/>
+                          </a:solidFill>
+                          <a:latin typeface="Arabic Typesetting" panose="03020402040406030203" pitchFamily="66" charset="-78"/>
+                          <a:ea typeface="Amiri" panose="00000500000000000000" pitchFamily="2" charset="-78"/>
+                          <a:cs typeface="Arabic Typesetting" panose="03020402040406030203" pitchFamily="66" charset="-78"/>
+                        </a:rPr>
+                        <a:t>كُلِّ شَيْءٍ</a:t>
+                      </a:r>
+                      <a:r>
+                        <a:rPr lang="ar-AE" sz="1600" b="1" kern="1200" dirty="0">
+                          <a:solidFill>
+                            <a:schemeClr val="accent6">
+                              <a:lumMod val="50000"/>
+                            </a:schemeClr>
+                          </a:solidFill>
+                          <a:latin typeface="Arabic Typesetting" panose="03020402040406030203" pitchFamily="66" charset="-78"/>
+                          <a:ea typeface="Amiri" panose="00000500000000000000" pitchFamily="2" charset="-78"/>
+                          <a:cs typeface="Arabic Typesetting" panose="03020402040406030203" pitchFamily="66" charset="-78"/>
+                        </a:rPr>
+                        <a:t>  </a:t>
+                      </a:r>
+                      <a:r>
+                        <a:rPr lang="tr-TR" sz="1600" b="1" kern="1200" dirty="0">
+                          <a:solidFill>
+                            <a:schemeClr val="accent6">
+                              <a:lumMod val="50000"/>
+                            </a:schemeClr>
+                          </a:solidFill>
+                          <a:latin typeface="Arabic Typesetting" panose="03020402040406030203" pitchFamily="66" charset="-78"/>
+                          <a:ea typeface="Amiri" panose="00000500000000000000" pitchFamily="2" charset="-78"/>
+                          <a:cs typeface="Arabic Typesetting" panose="03020402040406030203" pitchFamily="66" charset="-78"/>
+                        </a:rPr>
+                        <a:t>   </a:t>
+                      </a:r>
+                      <a:r>
+                        <a:rPr lang="tr-TR" sz="1600" b="1" kern="1200" dirty="0">
+                          <a:solidFill>
+                            <a:schemeClr val="tx1"/>
+                          </a:solidFill>
+                          <a:latin typeface="Arabic Typesetting" panose="03020402040406030203" pitchFamily="66" charset="-78"/>
+                          <a:ea typeface="Amiri" panose="00000500000000000000" pitchFamily="2" charset="-78"/>
+                          <a:cs typeface="Arabic Typesetting" panose="03020402040406030203" pitchFamily="66" charset="-78"/>
+                        </a:rPr>
+                        <a:t>/</a:t>
+                      </a:r>
+                      <a:r>
+                        <a:rPr lang="tr-TR" sz="1600" b="1" kern="1200" dirty="0">
+                          <a:solidFill>
+                            <a:schemeClr val="accent6">
+                              <a:lumMod val="50000"/>
+                            </a:schemeClr>
+                          </a:solidFill>
+                          <a:latin typeface="Arabic Typesetting" panose="03020402040406030203" pitchFamily="66" charset="-78"/>
+                          <a:ea typeface="Amiri" panose="00000500000000000000" pitchFamily="2" charset="-78"/>
+                          <a:cs typeface="Arabic Typesetting" panose="03020402040406030203" pitchFamily="66" charset="-78"/>
+                        </a:rPr>
+                        <a:t>  </a:t>
+                      </a:r>
+                      <a:r>
+                        <a:rPr lang="tr-TR" sz="1600" b="1" kern="1200" dirty="0">
+                          <a:solidFill>
+                            <a:schemeClr val="tx1"/>
+                          </a:solidFill>
+                          <a:latin typeface="Arabic Typesetting" panose="03020402040406030203" pitchFamily="66" charset="-78"/>
+                          <a:ea typeface="Amiri" panose="00000500000000000000" pitchFamily="2" charset="-78"/>
+                          <a:cs typeface="Arabic Typesetting" panose="03020402040406030203" pitchFamily="66" charset="-78"/>
+                        </a:rPr>
+                        <a:t>Muhakkak ki </a:t>
+                      </a:r>
+                      <a:r>
+                        <a:rPr lang="tr-TR" sz="1600" b="1" kern="1200" dirty="0" err="1">
+                          <a:solidFill>
+                            <a:schemeClr val="tx1"/>
+                          </a:solidFill>
+                          <a:latin typeface="Arabic Typesetting" panose="03020402040406030203" pitchFamily="66" charset="-78"/>
+                          <a:ea typeface="Amiri" panose="00000500000000000000" pitchFamily="2" charset="-78"/>
+                          <a:cs typeface="Arabic Typesetting" panose="03020402040406030203" pitchFamily="66" charset="-78"/>
+                        </a:rPr>
+                        <a:t>Allah’u</a:t>
+                      </a:r>
+                      <a:r>
+                        <a:rPr lang="tr-TR" sz="1600" b="1" kern="1200" dirty="0">
+                          <a:solidFill>
+                            <a:schemeClr val="tx1"/>
+                          </a:solidFill>
+                          <a:latin typeface="Arabic Typesetting" panose="03020402040406030203" pitchFamily="66" charset="-78"/>
+                          <a:ea typeface="Amiri" panose="00000500000000000000" pitchFamily="2" charset="-78"/>
+                          <a:cs typeface="Arabic Typesetting" panose="03020402040406030203" pitchFamily="66" charset="-78"/>
+                        </a:rPr>
+                        <a:t> Teala her şeyi bilicidir.</a:t>
+                      </a:r>
+                      <a:endParaRPr lang="tr-TR" sz="1600" b="1" kern="1200" dirty="0">
+                        <a:solidFill>
+                          <a:schemeClr val="accent6">
+                            <a:lumMod val="50000"/>
+                          </a:schemeClr>
+                        </a:solidFill>
+                        <a:latin typeface="Arabic Typesetting" panose="03020402040406030203" pitchFamily="66" charset="-78"/>
+                        <a:ea typeface="Amiri" panose="00000500000000000000" pitchFamily="2" charset="-78"/>
+                        <a:cs typeface="Arabic Typesetting" panose="03020402040406030203" pitchFamily="66" charset="-78"/>
+                      </a:endParaRPr>
+                    </a:p>
+                  </a:txBody>
+                  <a:tcPr/>
+                </a:tc>
+                <a:extLst>
+                  <a:ext uri="{0D108BD9-81ED-4DB2-BD59-A6C34878D82A}">
+                    <a16:rowId xmlns:a16="http://schemas.microsoft.com/office/drawing/2014/main" val="3898272618"/>
+                  </a:ext>
+                </a:extLst>
+              </a:tr>
+              <a:tr h="449333">
+                <a:tc>
+                  <a:txBody>
+                    <a:bodyPr/>
+                    <a:lstStyle/>
+                    <a:p>
+                      <a:pPr algn="ctr"/>
+                      <a:r>
+                        <a:rPr lang="ar-AE" sz="2400" b="1" dirty="0">
+                          <a:solidFill>
+                            <a:srgbClr val="C00000"/>
+                          </a:solidFill>
+                          <a:latin typeface="Algerian" panose="04020705040A02060702" pitchFamily="82" charset="0"/>
+                        </a:rPr>
+                        <a:t>أَنَّ</a:t>
+                      </a:r>
+                      <a:endParaRPr lang="tr-TR" sz="2400" b="1" dirty="0">
+                        <a:solidFill>
+                          <a:srgbClr val="C00000"/>
+                        </a:solidFill>
+                        <a:latin typeface="Algerian" panose="04020705040A02060702" pitchFamily="82" charset="0"/>
+                      </a:endParaRPr>
+                    </a:p>
+                  </a:txBody>
+                  <a:tcPr/>
+                </a:tc>
+                <a:tc>
+                  <a:txBody>
+                    <a:bodyPr/>
+                    <a:lstStyle/>
+                    <a:p>
+                      <a:pPr algn="ctr"/>
+                      <a:r>
+                        <a:rPr lang="tr-TR" sz="1800" dirty="0"/>
+                        <a:t>Muhakkak Ki </a:t>
+                      </a:r>
+                    </a:p>
+                  </a:txBody>
+                  <a:tcPr/>
+                </a:tc>
+                <a:tc>
+                  <a:txBody>
+                    <a:bodyPr/>
+                    <a:lstStyle/>
+                    <a:p>
+                      <a:pPr algn="ctr"/>
+                      <a:r>
+                        <a:rPr lang="ar-AE" sz="1600" b="1" dirty="0">
+                          <a:solidFill>
+                            <a:schemeClr val="tx1"/>
+                          </a:solidFill>
+                          <a:latin typeface="Arabic Typesetting" panose="03020402040406030203" pitchFamily="66" charset="-78"/>
+                          <a:cs typeface="Arabic Typesetting" panose="03020402040406030203" pitchFamily="66" charset="-78"/>
+                        </a:rPr>
+                        <a:t>إِعْتَقَدْتُ </a:t>
+                      </a:r>
+                      <a:r>
+                        <a:rPr lang="ar-AE" sz="1600" b="1" dirty="0">
+                          <a:solidFill>
+                            <a:srgbClr val="C00000"/>
+                          </a:solidFill>
+                          <a:latin typeface="Arabic Typesetting" panose="03020402040406030203" pitchFamily="66" charset="-78"/>
+                          <a:cs typeface="Arabic Typesetting" panose="03020402040406030203" pitchFamily="66" charset="-78"/>
+                        </a:rPr>
+                        <a:t>أَنَّ</a:t>
+                      </a:r>
+                      <a:r>
+                        <a:rPr lang="ar-AE" sz="1600" b="1" dirty="0">
+                          <a:solidFill>
+                            <a:schemeClr val="tx1"/>
+                          </a:solidFill>
+                          <a:latin typeface="Arabic Typesetting" panose="03020402040406030203" pitchFamily="66" charset="-78"/>
+                          <a:cs typeface="Arabic Typesetting" panose="03020402040406030203" pitchFamily="66" charset="-78"/>
+                        </a:rPr>
+                        <a:t> </a:t>
+                      </a:r>
+                      <a:r>
+                        <a:rPr lang="ar-AE" sz="1600" b="1" dirty="0">
+                          <a:solidFill>
+                            <a:srgbClr val="0000CC"/>
+                          </a:solidFill>
+                          <a:latin typeface="Arabic Typesetting" panose="03020402040406030203" pitchFamily="66" charset="-78"/>
+                          <a:cs typeface="Arabic Typesetting" panose="03020402040406030203" pitchFamily="66" charset="-78"/>
+                        </a:rPr>
+                        <a:t>اللَّهَ</a:t>
+                      </a:r>
+                      <a:r>
+                        <a:rPr lang="ar-AE" sz="1600" b="1" dirty="0">
+                          <a:solidFill>
+                            <a:schemeClr val="tx1"/>
+                          </a:solidFill>
+                          <a:latin typeface="Arabic Typesetting" panose="03020402040406030203" pitchFamily="66" charset="-78"/>
+                          <a:cs typeface="Arabic Typesetting" panose="03020402040406030203" pitchFamily="66" charset="-78"/>
+                        </a:rPr>
+                        <a:t> تَعَالَى </a:t>
+                      </a:r>
+                      <a:r>
+                        <a:rPr lang="ar-AE" sz="1600" b="1" dirty="0">
+                          <a:solidFill>
+                            <a:schemeClr val="accent6">
+                              <a:lumMod val="50000"/>
+                            </a:schemeClr>
+                          </a:solidFill>
+                          <a:latin typeface="Arabic Typesetting" panose="03020402040406030203" pitchFamily="66" charset="-78"/>
+                          <a:cs typeface="Arabic Typesetting" panose="03020402040406030203" pitchFamily="66" charset="-78"/>
+                        </a:rPr>
+                        <a:t>قَادِرٌ</a:t>
+                      </a:r>
+                      <a:r>
+                        <a:rPr lang="ar-AE" sz="1600" b="1" dirty="0">
+                          <a:solidFill>
+                            <a:schemeClr val="tx1"/>
+                          </a:solidFill>
+                          <a:latin typeface="Arabic Typesetting" panose="03020402040406030203" pitchFamily="66" charset="-78"/>
+                          <a:cs typeface="Arabic Typesetting" panose="03020402040406030203" pitchFamily="66" charset="-78"/>
+                        </a:rPr>
+                        <a:t> عَلَي كُلِّ شَيْءٍ</a:t>
+                      </a:r>
+                      <a:r>
+                        <a:rPr lang="tr-TR" sz="1600" b="1" dirty="0">
+                          <a:solidFill>
+                            <a:schemeClr val="tx1"/>
+                          </a:solidFill>
+                          <a:latin typeface="Arabic Typesetting" panose="03020402040406030203" pitchFamily="66" charset="-78"/>
+                          <a:cs typeface="Arabic Typesetting" panose="03020402040406030203" pitchFamily="66" charset="-78"/>
+                        </a:rPr>
+                        <a:t>  / Muhakkak ki </a:t>
+                      </a:r>
+                      <a:r>
+                        <a:rPr lang="tr-TR" sz="1600" b="1" dirty="0" err="1">
+                          <a:solidFill>
+                            <a:schemeClr val="tx1"/>
+                          </a:solidFill>
+                          <a:latin typeface="Arabic Typesetting" panose="03020402040406030203" pitchFamily="66" charset="-78"/>
+                          <a:cs typeface="Arabic Typesetting" panose="03020402040406030203" pitchFamily="66" charset="-78"/>
+                        </a:rPr>
+                        <a:t>Allah’u</a:t>
+                      </a:r>
+                      <a:r>
+                        <a:rPr lang="tr-TR" sz="1600" b="1" dirty="0">
+                          <a:solidFill>
+                            <a:schemeClr val="tx1"/>
+                          </a:solidFill>
+                          <a:latin typeface="Arabic Typesetting" panose="03020402040406030203" pitchFamily="66" charset="-78"/>
+                          <a:cs typeface="Arabic Typesetting" panose="03020402040406030203" pitchFamily="66" charset="-78"/>
+                        </a:rPr>
+                        <a:t> Teala’nın her şey üzerine kadir olduğuna itikat ettim.</a:t>
+                      </a:r>
+                    </a:p>
+                  </a:txBody>
+                  <a:tcPr/>
+                </a:tc>
+                <a:extLst>
+                  <a:ext uri="{0D108BD9-81ED-4DB2-BD59-A6C34878D82A}">
+                    <a16:rowId xmlns:a16="http://schemas.microsoft.com/office/drawing/2014/main" val="2209876613"/>
+                  </a:ext>
+                </a:extLst>
+              </a:tr>
+              <a:tr h="463320">
+                <a:tc>
+                  <a:txBody>
+                    <a:bodyPr/>
+                    <a:lstStyle/>
+                    <a:p>
+                      <a:pPr algn="ctr"/>
+                      <a:r>
+                        <a:rPr lang="ar-AE" sz="2400" b="1" dirty="0">
+                          <a:solidFill>
+                            <a:srgbClr val="C00000"/>
+                          </a:solidFill>
+                          <a:latin typeface="Algerian" panose="04020705040A02060702" pitchFamily="82" charset="0"/>
+                        </a:rPr>
+                        <a:t>كَأَنَّ</a:t>
+                      </a:r>
+                      <a:endParaRPr lang="tr-TR" sz="2400" b="1" dirty="0">
+                        <a:solidFill>
+                          <a:srgbClr val="C00000"/>
+                        </a:solidFill>
+                        <a:latin typeface="Algerian" panose="04020705040A02060702" pitchFamily="82" charset="0"/>
+                      </a:endParaRPr>
+                    </a:p>
+                  </a:txBody>
+                  <a:tcPr/>
+                </a:tc>
+                <a:tc>
+                  <a:txBody>
+                    <a:bodyPr/>
+                    <a:lstStyle/>
+                    <a:p>
+                      <a:pPr algn="ctr"/>
+                      <a:r>
+                        <a:rPr lang="tr-TR" sz="1800" dirty="0"/>
+                        <a:t>Gibi </a:t>
+                      </a:r>
+                    </a:p>
+                  </a:txBody>
+                  <a:tcPr/>
+                </a:tc>
+                <a:tc>
+                  <a:txBody>
+                    <a:bodyPr/>
+                    <a:lstStyle/>
+                    <a:p>
+                      <a:pPr algn="ctr"/>
+                      <a:r>
+                        <a:rPr lang="ar-AE" sz="1600" b="1" dirty="0">
+                          <a:solidFill>
+                            <a:srgbClr val="C00000"/>
+                          </a:solidFill>
+                          <a:latin typeface="Arabic Typesetting" panose="03020402040406030203" pitchFamily="66" charset="-78"/>
+                          <a:cs typeface="Arabic Typesetting" panose="03020402040406030203" pitchFamily="66" charset="-78"/>
+                        </a:rPr>
+                        <a:t>كَأَنَّ</a:t>
+                      </a:r>
+                      <a:r>
+                        <a:rPr lang="ar-AE" sz="1600" b="1" dirty="0">
+                          <a:latin typeface="Arabic Typesetting" panose="03020402040406030203" pitchFamily="66" charset="-78"/>
+                          <a:cs typeface="Arabic Typesetting" panose="03020402040406030203" pitchFamily="66" charset="-78"/>
+                        </a:rPr>
+                        <a:t> </a:t>
+                      </a:r>
+                      <a:r>
+                        <a:rPr lang="ar-AE" sz="1600" b="1" dirty="0">
+                          <a:solidFill>
+                            <a:srgbClr val="0000CC"/>
+                          </a:solidFill>
+                          <a:latin typeface="Arabic Typesetting" panose="03020402040406030203" pitchFamily="66" charset="-78"/>
+                          <a:cs typeface="Arabic Typesetting" panose="03020402040406030203" pitchFamily="66" charset="-78"/>
+                        </a:rPr>
+                        <a:t>الْحَرَامَ</a:t>
+                      </a:r>
+                      <a:r>
+                        <a:rPr lang="ar-AE" sz="1600" b="1" dirty="0">
+                          <a:latin typeface="Arabic Typesetting" panose="03020402040406030203" pitchFamily="66" charset="-78"/>
+                          <a:cs typeface="Arabic Typesetting" panose="03020402040406030203" pitchFamily="66" charset="-78"/>
+                        </a:rPr>
+                        <a:t> </a:t>
+                      </a:r>
+                      <a:r>
+                        <a:rPr lang="ar-AE" sz="1600" b="1" dirty="0">
+                          <a:solidFill>
+                            <a:schemeClr val="accent6">
+                              <a:lumMod val="50000"/>
+                            </a:schemeClr>
+                          </a:solidFill>
+                          <a:latin typeface="Arabic Typesetting" panose="03020402040406030203" pitchFamily="66" charset="-78"/>
+                          <a:cs typeface="Arabic Typesetting" panose="03020402040406030203" pitchFamily="66" charset="-78"/>
+                        </a:rPr>
+                        <a:t>نَارٌ</a:t>
+                      </a:r>
+                      <a:r>
+                        <a:rPr lang="tr-TR" sz="1600" b="1" dirty="0">
+                          <a:solidFill>
+                            <a:schemeClr val="accent6">
+                              <a:lumMod val="50000"/>
+                            </a:schemeClr>
+                          </a:solidFill>
+                          <a:latin typeface="Arabic Typesetting" panose="03020402040406030203" pitchFamily="66" charset="-78"/>
+                          <a:cs typeface="Arabic Typesetting" panose="03020402040406030203" pitchFamily="66" charset="-78"/>
+                        </a:rPr>
+                        <a:t>  </a:t>
+                      </a:r>
+                      <a:r>
+                        <a:rPr lang="tr-TR" sz="1600" b="1" dirty="0">
+                          <a:solidFill>
+                            <a:schemeClr val="tx1"/>
+                          </a:solidFill>
+                          <a:latin typeface="Arabic Typesetting" panose="03020402040406030203" pitchFamily="66" charset="-78"/>
+                          <a:cs typeface="Arabic Typesetting" panose="03020402040406030203" pitchFamily="66" charset="-78"/>
+                        </a:rPr>
+                        <a:t>/</a:t>
+                      </a:r>
+                      <a:r>
+                        <a:rPr lang="tr-TR" sz="1600" b="1" dirty="0">
+                          <a:solidFill>
+                            <a:schemeClr val="accent6">
+                              <a:lumMod val="50000"/>
+                            </a:schemeClr>
+                          </a:solidFill>
+                          <a:latin typeface="Arabic Typesetting" panose="03020402040406030203" pitchFamily="66" charset="-78"/>
+                          <a:cs typeface="Arabic Typesetting" panose="03020402040406030203" pitchFamily="66" charset="-78"/>
+                        </a:rPr>
+                        <a:t>  </a:t>
+                      </a:r>
+                      <a:r>
+                        <a:rPr lang="tr-TR" sz="1600" b="1" dirty="0">
+                          <a:solidFill>
+                            <a:schemeClr val="tx1"/>
+                          </a:solidFill>
+                          <a:latin typeface="Arabic Typesetting" panose="03020402040406030203" pitchFamily="66" charset="-78"/>
+                          <a:cs typeface="Arabic Typesetting" panose="03020402040406030203" pitchFamily="66" charset="-78"/>
+                        </a:rPr>
+                        <a:t>Haram sanki ateş gibidir.</a:t>
+                      </a:r>
+                    </a:p>
+                  </a:txBody>
+                  <a:tcPr/>
+                </a:tc>
+                <a:extLst>
+                  <a:ext uri="{0D108BD9-81ED-4DB2-BD59-A6C34878D82A}">
+                    <a16:rowId xmlns:a16="http://schemas.microsoft.com/office/drawing/2014/main" val="1718483269"/>
+                  </a:ext>
+                </a:extLst>
+              </a:tr>
+              <a:tr h="463320">
+                <a:tc>
+                  <a:txBody>
+                    <a:bodyPr/>
+                    <a:lstStyle/>
+                    <a:p>
+                      <a:pPr algn="ctr"/>
+                      <a:r>
+                        <a:rPr lang="ar-AE" sz="2400" b="1" dirty="0">
+                          <a:solidFill>
+                            <a:srgbClr val="C00000"/>
+                          </a:solidFill>
+                          <a:latin typeface="Algerian" panose="04020705040A02060702" pitchFamily="82" charset="0"/>
+                        </a:rPr>
+                        <a:t>لَكِنَّ</a:t>
+                      </a:r>
+                      <a:endParaRPr lang="tr-TR" sz="2400" b="1" dirty="0">
+                        <a:solidFill>
+                          <a:srgbClr val="C00000"/>
+                        </a:solidFill>
+                        <a:latin typeface="Algerian" panose="04020705040A02060702" pitchFamily="82" charset="0"/>
+                      </a:endParaRPr>
+                    </a:p>
+                  </a:txBody>
+                  <a:tcPr/>
+                </a:tc>
+                <a:tc>
+                  <a:txBody>
+                    <a:bodyPr/>
+                    <a:lstStyle/>
+                    <a:p>
+                      <a:pPr algn="ctr"/>
+                      <a:r>
+                        <a:rPr lang="tr-TR" sz="1800" dirty="0"/>
+                        <a:t>Ancak</a:t>
+                      </a:r>
+                    </a:p>
+                  </a:txBody>
+                  <a:tcPr/>
+                </a:tc>
+                <a:tc>
+                  <a:txBody>
+                    <a:bodyPr/>
+                    <a:lstStyle/>
+                    <a:p>
+                      <a:pPr algn="ctr"/>
+                      <a:r>
+                        <a:rPr lang="ar-AE" sz="1600" b="1" dirty="0">
+                          <a:latin typeface="Arabic Typesetting" panose="03020402040406030203" pitchFamily="66" charset="-78"/>
+                          <a:cs typeface="Arabic Typesetting" panose="03020402040406030203" pitchFamily="66" charset="-78"/>
+                        </a:rPr>
+                        <a:t>مَا فَازَ الْجَاهِلُ </a:t>
+                      </a:r>
+                      <a:r>
+                        <a:rPr lang="ar-AE" sz="1600" b="1" dirty="0">
+                          <a:solidFill>
+                            <a:srgbClr val="C00000"/>
+                          </a:solidFill>
+                          <a:latin typeface="Arabic Typesetting" panose="03020402040406030203" pitchFamily="66" charset="-78"/>
+                          <a:cs typeface="Arabic Typesetting" panose="03020402040406030203" pitchFamily="66" charset="-78"/>
+                        </a:rPr>
+                        <a:t>لَكِنَّ</a:t>
+                      </a:r>
+                      <a:r>
+                        <a:rPr lang="ar-AE" sz="1600" b="1" dirty="0">
+                          <a:latin typeface="Arabic Typesetting" panose="03020402040406030203" pitchFamily="66" charset="-78"/>
+                          <a:cs typeface="Arabic Typesetting" panose="03020402040406030203" pitchFamily="66" charset="-78"/>
+                        </a:rPr>
+                        <a:t> </a:t>
+                      </a:r>
+                      <a:r>
+                        <a:rPr lang="ar-AE" sz="1600" b="1" dirty="0">
+                          <a:solidFill>
+                            <a:srgbClr val="0000CC"/>
+                          </a:solidFill>
+                          <a:latin typeface="Arabic Typesetting" panose="03020402040406030203" pitchFamily="66" charset="-78"/>
+                          <a:cs typeface="Arabic Typesetting" panose="03020402040406030203" pitchFamily="66" charset="-78"/>
+                        </a:rPr>
+                        <a:t>الْعَالِمَ</a:t>
+                      </a:r>
+                      <a:r>
+                        <a:rPr lang="ar-AE" sz="1600" b="1" dirty="0">
+                          <a:latin typeface="Arabic Typesetting" panose="03020402040406030203" pitchFamily="66" charset="-78"/>
+                          <a:cs typeface="Arabic Typesetting" panose="03020402040406030203" pitchFamily="66" charset="-78"/>
+                        </a:rPr>
+                        <a:t> </a:t>
+                      </a:r>
+                      <a:r>
+                        <a:rPr lang="ar-AE" sz="1600" b="1" dirty="0">
+                          <a:solidFill>
+                            <a:schemeClr val="accent6">
+                              <a:lumMod val="50000"/>
+                            </a:schemeClr>
+                          </a:solidFill>
+                          <a:latin typeface="Arabic Typesetting" panose="03020402040406030203" pitchFamily="66" charset="-78"/>
+                          <a:cs typeface="Arabic Typesetting" panose="03020402040406030203" pitchFamily="66" charset="-78"/>
+                        </a:rPr>
+                        <a:t>فَائِزٌ</a:t>
+                      </a:r>
+                      <a:r>
+                        <a:rPr lang="tr-TR" sz="1600" b="1" dirty="0">
+                          <a:solidFill>
+                            <a:schemeClr val="accent6">
+                              <a:lumMod val="50000"/>
+                            </a:schemeClr>
+                          </a:solidFill>
+                          <a:latin typeface="Arabic Typesetting" panose="03020402040406030203" pitchFamily="66" charset="-78"/>
+                          <a:cs typeface="Arabic Typesetting" panose="03020402040406030203" pitchFamily="66" charset="-78"/>
+                        </a:rPr>
+                        <a:t> </a:t>
+                      </a:r>
+                      <a:r>
+                        <a:rPr lang="tr-TR" sz="1600" b="1" dirty="0">
+                          <a:solidFill>
+                            <a:schemeClr val="tx1"/>
+                          </a:solidFill>
+                          <a:latin typeface="Arabic Typesetting" panose="03020402040406030203" pitchFamily="66" charset="-78"/>
+                          <a:cs typeface="Arabic Typesetting" panose="03020402040406030203" pitchFamily="66" charset="-78"/>
+                        </a:rPr>
+                        <a:t>/ Cahil kurtulmadı fakat alim </a:t>
+                      </a:r>
+                      <a:r>
+                        <a:rPr lang="tr-TR" sz="1600" b="1" dirty="0" err="1">
+                          <a:solidFill>
+                            <a:schemeClr val="tx1"/>
+                          </a:solidFill>
+                          <a:latin typeface="Arabic Typesetting" panose="03020402040406030203" pitchFamily="66" charset="-78"/>
+                          <a:cs typeface="Arabic Typesetting" panose="03020402040406030203" pitchFamily="66" charset="-78"/>
+                        </a:rPr>
+                        <a:t>kurtulucudur</a:t>
+                      </a:r>
+                      <a:r>
+                        <a:rPr lang="tr-TR" sz="1600" b="1" dirty="0">
+                          <a:solidFill>
+                            <a:schemeClr val="tx1"/>
+                          </a:solidFill>
+                          <a:latin typeface="Arabic Typesetting" panose="03020402040406030203" pitchFamily="66" charset="-78"/>
+                          <a:cs typeface="Arabic Typesetting" panose="03020402040406030203" pitchFamily="66" charset="-78"/>
+                        </a:rPr>
+                        <a:t>.</a:t>
+                      </a:r>
+                    </a:p>
+                  </a:txBody>
+                  <a:tcPr/>
+                </a:tc>
+                <a:extLst>
+                  <a:ext uri="{0D108BD9-81ED-4DB2-BD59-A6C34878D82A}">
+                    <a16:rowId xmlns:a16="http://schemas.microsoft.com/office/drawing/2014/main" val="98950525"/>
+                  </a:ext>
+                </a:extLst>
+              </a:tr>
+              <a:tr h="449333">
+                <a:tc>
+                  <a:txBody>
+                    <a:bodyPr/>
+                    <a:lstStyle/>
+                    <a:p>
+                      <a:pPr algn="ctr"/>
+                      <a:r>
+                        <a:rPr lang="ar-AE" sz="2400" b="1" dirty="0">
+                          <a:solidFill>
+                            <a:srgbClr val="C00000"/>
+                          </a:solidFill>
+                          <a:latin typeface="Algerian" panose="04020705040A02060702" pitchFamily="82" charset="0"/>
+                        </a:rPr>
+                        <a:t>لَيْتَ</a:t>
+                      </a:r>
+                      <a:endParaRPr lang="tr-TR" sz="2400" b="1" dirty="0">
+                        <a:solidFill>
+                          <a:srgbClr val="C00000"/>
+                        </a:solidFill>
+                        <a:latin typeface="Algerian" panose="04020705040A02060702" pitchFamily="82" charset="0"/>
+                      </a:endParaRPr>
+                    </a:p>
+                  </a:txBody>
+                  <a:tcPr/>
+                </a:tc>
+                <a:tc>
+                  <a:txBody>
+                    <a:bodyPr/>
+                    <a:lstStyle/>
+                    <a:p>
+                      <a:pPr algn="ctr"/>
+                      <a:r>
+                        <a:rPr lang="tr-TR" sz="1800" dirty="0"/>
+                        <a:t>Keşke</a:t>
+                      </a:r>
+                    </a:p>
+                  </a:txBody>
+                  <a:tcPr/>
+                </a:tc>
+                <a:tc>
+                  <a:txBody>
+                    <a:bodyPr/>
+                    <a:lstStyle/>
+                    <a:p>
+                      <a:pPr algn="ctr"/>
+                      <a:r>
+                        <a:rPr lang="ar-AE" sz="1600" b="1" dirty="0">
+                          <a:solidFill>
+                            <a:srgbClr val="C00000"/>
+                          </a:solidFill>
+                          <a:latin typeface="Arabic Typesetting" panose="03020402040406030203" pitchFamily="66" charset="-78"/>
+                          <a:cs typeface="Arabic Typesetting" panose="03020402040406030203" pitchFamily="66" charset="-78"/>
+                        </a:rPr>
+                        <a:t>لَيْتَ</a:t>
+                      </a:r>
+                      <a:r>
+                        <a:rPr lang="ar-AE" sz="1600" b="1" dirty="0">
+                          <a:latin typeface="Arabic Typesetting" panose="03020402040406030203" pitchFamily="66" charset="-78"/>
+                          <a:cs typeface="Arabic Typesetting" panose="03020402040406030203" pitchFamily="66" charset="-78"/>
+                        </a:rPr>
+                        <a:t> </a:t>
+                      </a:r>
+                      <a:r>
+                        <a:rPr lang="ar-AE" sz="1600" b="1" dirty="0">
+                          <a:solidFill>
+                            <a:srgbClr val="0000CC"/>
+                          </a:solidFill>
+                          <a:latin typeface="Arabic Typesetting" panose="03020402040406030203" pitchFamily="66" charset="-78"/>
+                          <a:cs typeface="Arabic Typesetting" panose="03020402040406030203" pitchFamily="66" charset="-78"/>
+                        </a:rPr>
+                        <a:t>الْعِلْمَ</a:t>
+                      </a:r>
+                      <a:r>
+                        <a:rPr lang="ar-AE" sz="1600" b="1" dirty="0">
+                          <a:latin typeface="Arabic Typesetting" panose="03020402040406030203" pitchFamily="66" charset="-78"/>
+                          <a:cs typeface="Arabic Typesetting" panose="03020402040406030203" pitchFamily="66" charset="-78"/>
+                        </a:rPr>
+                        <a:t> </a:t>
+                      </a:r>
+                      <a:r>
+                        <a:rPr lang="ar-AE" sz="1600" b="1" dirty="0">
+                          <a:solidFill>
+                            <a:schemeClr val="accent6">
+                              <a:lumMod val="50000"/>
+                            </a:schemeClr>
+                          </a:solidFill>
+                          <a:latin typeface="Arabic Typesetting" panose="03020402040406030203" pitchFamily="66" charset="-78"/>
+                          <a:cs typeface="Arabic Typesetting" panose="03020402040406030203" pitchFamily="66" charset="-78"/>
+                        </a:rPr>
+                        <a:t>مَرْزُوقٌ</a:t>
+                      </a:r>
+                      <a:r>
+                        <a:rPr lang="ar-AE" sz="1600" b="1" dirty="0">
+                          <a:latin typeface="Arabic Typesetting" panose="03020402040406030203" pitchFamily="66" charset="-78"/>
+                          <a:cs typeface="Arabic Typesetting" panose="03020402040406030203" pitchFamily="66" charset="-78"/>
+                        </a:rPr>
+                        <a:t> لِكُلِّ أَحَدٍ</a:t>
+                      </a:r>
+                      <a:r>
+                        <a:rPr lang="tr-TR" sz="1600" b="1" dirty="0">
+                          <a:latin typeface="Arabic Typesetting" panose="03020402040406030203" pitchFamily="66" charset="-78"/>
+                          <a:cs typeface="Arabic Typesetting" panose="03020402040406030203" pitchFamily="66" charset="-78"/>
+                        </a:rPr>
+                        <a:t> / Keşke ilim herkese rızık olsaydı.</a:t>
+                      </a:r>
+                    </a:p>
+                  </a:txBody>
+                  <a:tcPr/>
+                </a:tc>
+                <a:extLst>
+                  <a:ext uri="{0D108BD9-81ED-4DB2-BD59-A6C34878D82A}">
+                    <a16:rowId xmlns:a16="http://schemas.microsoft.com/office/drawing/2014/main" val="3359397602"/>
+                  </a:ext>
+                </a:extLst>
+              </a:tr>
+              <a:tr h="449333">
+                <a:tc>
+                  <a:txBody>
+                    <a:bodyPr/>
+                    <a:lstStyle/>
+                    <a:p>
+                      <a:pPr algn="ctr"/>
+                      <a:r>
+                        <a:rPr lang="ar-AE" sz="2400" b="1" dirty="0">
+                          <a:solidFill>
+                            <a:srgbClr val="C00000"/>
+                          </a:solidFill>
+                          <a:latin typeface="Algerian" panose="04020705040A02060702" pitchFamily="82" charset="0"/>
+                        </a:rPr>
+                        <a:t>لَعَلَّ</a:t>
+                      </a:r>
+                      <a:endParaRPr lang="tr-TR" sz="2400" b="1" dirty="0">
+                        <a:solidFill>
+                          <a:srgbClr val="C00000"/>
+                        </a:solidFill>
+                        <a:latin typeface="Algerian" panose="04020705040A02060702" pitchFamily="82" charset="0"/>
+                      </a:endParaRPr>
+                    </a:p>
+                  </a:txBody>
+                  <a:tcPr/>
+                </a:tc>
+                <a:tc>
+                  <a:txBody>
+                    <a:bodyPr/>
+                    <a:lstStyle/>
+                    <a:p>
+                      <a:pPr algn="ctr"/>
+                      <a:r>
+                        <a:rPr lang="tr-TR" sz="1800" dirty="0"/>
+                        <a:t>Umulur ki</a:t>
+                      </a:r>
+                    </a:p>
+                  </a:txBody>
+                  <a:tcPr/>
+                </a:tc>
+                <a:tc>
+                  <a:txBody>
+                    <a:bodyPr/>
+                    <a:lstStyle/>
+                    <a:p>
+                      <a:pPr algn="ctr"/>
+                      <a:r>
+                        <a:rPr lang="ar-AE" sz="1600" b="1" dirty="0">
+                          <a:solidFill>
+                            <a:srgbClr val="C00000"/>
+                          </a:solidFill>
+                          <a:latin typeface="Arabic Typesetting" panose="03020402040406030203" pitchFamily="66" charset="-78"/>
+                          <a:cs typeface="Arabic Typesetting" panose="03020402040406030203" pitchFamily="66" charset="-78"/>
+                        </a:rPr>
+                        <a:t>لَعَلَّ</a:t>
+                      </a:r>
+                      <a:r>
+                        <a:rPr lang="ar-AE" sz="1600" b="1" dirty="0">
+                          <a:latin typeface="Arabic Typesetting" panose="03020402040406030203" pitchFamily="66" charset="-78"/>
+                          <a:cs typeface="Arabic Typesetting" panose="03020402040406030203" pitchFamily="66" charset="-78"/>
+                        </a:rPr>
+                        <a:t> </a:t>
+                      </a:r>
+                      <a:r>
+                        <a:rPr lang="ar-AE" sz="1600" b="1" dirty="0">
+                          <a:solidFill>
+                            <a:srgbClr val="0000CC"/>
+                          </a:solidFill>
+                          <a:latin typeface="Arabic Typesetting" panose="03020402040406030203" pitchFamily="66" charset="-78"/>
+                          <a:cs typeface="Arabic Typesetting" panose="03020402040406030203" pitchFamily="66" charset="-78"/>
+                        </a:rPr>
+                        <a:t>اللَّهَ</a:t>
+                      </a:r>
+                      <a:r>
+                        <a:rPr lang="ar-AE" sz="1600" b="1" dirty="0">
+                          <a:latin typeface="Arabic Typesetting" panose="03020402040406030203" pitchFamily="66" charset="-78"/>
+                          <a:cs typeface="Arabic Typesetting" panose="03020402040406030203" pitchFamily="66" charset="-78"/>
+                        </a:rPr>
+                        <a:t> تَعَالَى </a:t>
+                      </a:r>
+                      <a:r>
+                        <a:rPr lang="ar-AE" sz="1600" b="1" dirty="0">
+                          <a:solidFill>
+                            <a:schemeClr val="accent6">
+                              <a:lumMod val="50000"/>
+                            </a:schemeClr>
+                          </a:solidFill>
+                          <a:latin typeface="Arabic Typesetting" panose="03020402040406030203" pitchFamily="66" charset="-78"/>
+                          <a:cs typeface="Arabic Typesetting" panose="03020402040406030203" pitchFamily="66" charset="-78"/>
+                        </a:rPr>
+                        <a:t>غَافِرُ</a:t>
+                      </a:r>
+                      <a:r>
+                        <a:rPr lang="ar-AE" sz="1600" b="1" dirty="0">
+                          <a:latin typeface="Arabic Typesetting" panose="03020402040406030203" pitchFamily="66" charset="-78"/>
+                          <a:cs typeface="Arabic Typesetting" panose="03020402040406030203" pitchFamily="66" charset="-78"/>
+                        </a:rPr>
+                        <a:t> ذَنْبِي</a:t>
+                      </a:r>
+                      <a:r>
+                        <a:rPr lang="tr-TR" sz="1600" b="1" dirty="0">
+                          <a:latin typeface="Arabic Typesetting" panose="03020402040406030203" pitchFamily="66" charset="-78"/>
+                          <a:cs typeface="Arabic Typesetting" panose="03020402040406030203" pitchFamily="66" charset="-78"/>
+                        </a:rPr>
+                        <a:t> / Umulur ki Allah Teala günahımı mağfiret eder.</a:t>
+                      </a:r>
+                    </a:p>
+                  </a:txBody>
+                  <a:tcPr/>
+                </a:tc>
+                <a:extLst>
+                  <a:ext uri="{0D108BD9-81ED-4DB2-BD59-A6C34878D82A}">
+                    <a16:rowId xmlns:a16="http://schemas.microsoft.com/office/drawing/2014/main" val="4078668120"/>
+                  </a:ext>
+                </a:extLst>
+              </a:tr>
+              <a:tr h="463320">
+                <a:tc>
+                  <a:txBody>
+                    <a:bodyPr/>
+                    <a:lstStyle/>
+                    <a:p>
+                      <a:pPr algn="ctr"/>
+                      <a:r>
+                        <a:rPr lang="ar-AE" sz="2400" b="1" dirty="0">
+                          <a:solidFill>
+                            <a:srgbClr val="C00000"/>
+                          </a:solidFill>
+                          <a:latin typeface="Algerian" panose="04020705040A02060702" pitchFamily="82" charset="0"/>
+                        </a:rPr>
+                        <a:t>إِلَّا</a:t>
+                      </a:r>
+                      <a:endParaRPr lang="tr-TR" sz="2400" b="1" dirty="0">
+                        <a:solidFill>
+                          <a:srgbClr val="C00000"/>
+                        </a:solidFill>
+                        <a:latin typeface="Algerian" panose="04020705040A02060702" pitchFamily="82" charset="0"/>
+                      </a:endParaRPr>
+                    </a:p>
+                  </a:txBody>
+                  <a:tcPr/>
+                </a:tc>
+                <a:tc>
+                  <a:txBody>
+                    <a:bodyPr/>
+                    <a:lstStyle/>
+                    <a:p>
+                      <a:pPr algn="ctr"/>
+                      <a:r>
+                        <a:rPr lang="tr-TR" sz="1800" dirty="0"/>
+                        <a:t>Ancak</a:t>
+                      </a:r>
+                    </a:p>
+                  </a:txBody>
+                  <a:tcPr/>
+                </a:tc>
+                <a:tc>
+                  <a:txBody>
+                    <a:bodyPr/>
+                    <a:lstStyle/>
+                    <a:p>
+                      <a:pPr algn="ctr"/>
+                      <a:r>
+                        <a:rPr lang="ar-AE" sz="1600" b="1" dirty="0">
+                          <a:latin typeface="Arabic Typesetting" panose="03020402040406030203" pitchFamily="66" charset="-78"/>
+                          <a:cs typeface="Arabic Typesetting" panose="03020402040406030203" pitchFamily="66" charset="-78"/>
+                        </a:rPr>
+                        <a:t>اَلْمَعْصِيَّةُ مُبَعِّدَةٌ عَنِ الْجَنَّةِ </a:t>
+                      </a:r>
+                      <a:r>
+                        <a:rPr lang="ar-AE" sz="1600" b="1" dirty="0">
+                          <a:solidFill>
+                            <a:srgbClr val="C00000"/>
+                          </a:solidFill>
+                          <a:latin typeface="Arabic Typesetting" panose="03020402040406030203" pitchFamily="66" charset="-78"/>
+                          <a:cs typeface="Arabic Typesetting" panose="03020402040406030203" pitchFamily="66" charset="-78"/>
+                        </a:rPr>
+                        <a:t>إِلَّا</a:t>
+                      </a:r>
+                      <a:r>
+                        <a:rPr lang="ar-AE" sz="1600" b="1" dirty="0">
+                          <a:latin typeface="Arabic Typesetting" panose="03020402040406030203" pitchFamily="66" charset="-78"/>
+                          <a:cs typeface="Arabic Typesetting" panose="03020402040406030203" pitchFamily="66" charset="-78"/>
+                        </a:rPr>
+                        <a:t> </a:t>
+                      </a:r>
+                      <a:r>
+                        <a:rPr lang="ar-AE" sz="1600" b="1" dirty="0">
+                          <a:solidFill>
+                            <a:srgbClr val="0000CC"/>
+                          </a:solidFill>
+                          <a:latin typeface="Arabic Typesetting" panose="03020402040406030203" pitchFamily="66" charset="-78"/>
+                          <a:cs typeface="Arabic Typesetting" panose="03020402040406030203" pitchFamily="66" charset="-78"/>
+                        </a:rPr>
+                        <a:t>الطَّاعَةَ</a:t>
+                      </a:r>
+                      <a:r>
+                        <a:rPr lang="ar-AE" sz="1600" b="1" dirty="0">
+                          <a:latin typeface="Arabic Typesetting" panose="03020402040406030203" pitchFamily="66" charset="-78"/>
+                          <a:cs typeface="Arabic Typesetting" panose="03020402040406030203" pitchFamily="66" charset="-78"/>
+                        </a:rPr>
+                        <a:t> </a:t>
+                      </a:r>
+                      <a:r>
+                        <a:rPr lang="ar-AE" sz="1600" b="1" dirty="0">
+                          <a:solidFill>
+                            <a:schemeClr val="accent6">
+                              <a:lumMod val="50000"/>
+                            </a:schemeClr>
+                          </a:solidFill>
+                          <a:latin typeface="Arabic Typesetting" panose="03020402040406030203" pitchFamily="66" charset="-78"/>
+                          <a:cs typeface="Arabic Typesetting" panose="03020402040406030203" pitchFamily="66" charset="-78"/>
+                        </a:rPr>
+                        <a:t>مُقَرَّبَةٌ</a:t>
+                      </a:r>
+                      <a:r>
+                        <a:rPr lang="ar-AE" sz="1600" b="1" dirty="0">
+                          <a:latin typeface="Arabic Typesetting" panose="03020402040406030203" pitchFamily="66" charset="-78"/>
+                          <a:cs typeface="Arabic Typesetting" panose="03020402040406030203" pitchFamily="66" charset="-78"/>
+                        </a:rPr>
+                        <a:t> مِنْهَا</a:t>
+                      </a:r>
+                      <a:r>
+                        <a:rPr lang="tr-TR" sz="1600" b="1" dirty="0">
+                          <a:latin typeface="Arabic Typesetting" panose="03020402040406030203" pitchFamily="66" charset="-78"/>
+                          <a:cs typeface="Arabic Typesetting" panose="03020402040406030203" pitchFamily="66" charset="-78"/>
+                        </a:rPr>
+                        <a:t> / Günah cennetten uzaklaştırıcıdır. Ancak itaat ise ona yaklaştırıcıdır. </a:t>
+                      </a:r>
+                      <a:r>
+                        <a:rPr lang="tr-TR" sz="1600" b="1" u="sng" dirty="0">
+                          <a:solidFill>
+                            <a:schemeClr val="accent2">
+                              <a:lumMod val="50000"/>
+                            </a:schemeClr>
+                          </a:solidFill>
+                          <a:latin typeface="Arabic Typesetting" panose="03020402040406030203" pitchFamily="66" charset="-78"/>
+                          <a:cs typeface="Arabic Typesetting" panose="03020402040406030203" pitchFamily="66" charset="-78"/>
+                        </a:rPr>
+                        <a:t>(İstisna-i </a:t>
+                      </a:r>
+                      <a:r>
+                        <a:rPr lang="tr-TR" sz="1600" b="1" u="sng" dirty="0" err="1">
+                          <a:solidFill>
+                            <a:schemeClr val="accent2">
+                              <a:lumMod val="50000"/>
+                            </a:schemeClr>
+                          </a:solidFill>
+                          <a:latin typeface="Arabic Typesetting" panose="03020402040406030203" pitchFamily="66" charset="-78"/>
+                          <a:cs typeface="Arabic Typesetting" panose="03020402040406030203" pitchFamily="66" charset="-78"/>
+                        </a:rPr>
+                        <a:t>Munkatı</a:t>
+                      </a:r>
+                      <a:r>
+                        <a:rPr lang="tr-TR" sz="1600" b="1" u="sng" dirty="0">
+                          <a:solidFill>
+                            <a:schemeClr val="accent2">
+                              <a:lumMod val="50000"/>
+                            </a:schemeClr>
+                          </a:solidFill>
+                          <a:latin typeface="Arabic Typesetting" panose="03020402040406030203" pitchFamily="66" charset="-78"/>
+                          <a:cs typeface="Arabic Typesetting" panose="03020402040406030203" pitchFamily="66" charset="-78"/>
+                        </a:rPr>
+                        <a:t>)</a:t>
+                      </a:r>
+                    </a:p>
+                  </a:txBody>
+                  <a:tcPr/>
+                </a:tc>
+                <a:extLst>
+                  <a:ext uri="{0D108BD9-81ED-4DB2-BD59-A6C34878D82A}">
+                    <a16:rowId xmlns:a16="http://schemas.microsoft.com/office/drawing/2014/main" val="3184782361"/>
+                  </a:ext>
+                </a:extLst>
+              </a:tr>
+              <a:tr h="463320">
+                <a:tc>
+                  <a:txBody>
+                    <a:bodyPr/>
+                    <a:lstStyle/>
+                    <a:p>
+                      <a:pPr algn="ctr"/>
+                      <a:r>
+                        <a:rPr lang="ar-AE" sz="2400" b="1" dirty="0">
+                          <a:solidFill>
+                            <a:srgbClr val="C00000"/>
+                          </a:solidFill>
+                          <a:latin typeface="Algerian" panose="04020705040A02060702" pitchFamily="82" charset="0"/>
+                        </a:rPr>
+                        <a:t>لَا</a:t>
+                      </a:r>
+                      <a:endParaRPr lang="tr-TR" sz="2400" b="1" dirty="0">
+                        <a:solidFill>
+                          <a:srgbClr val="C00000"/>
+                        </a:solidFill>
+                        <a:latin typeface="Algerian" panose="04020705040A02060702" pitchFamily="82" charset="0"/>
+                      </a:endParaRPr>
+                    </a:p>
+                  </a:txBody>
+                  <a:tcPr/>
+                </a:tc>
+                <a:tc>
+                  <a:txBody>
+                    <a:bodyPr/>
+                    <a:lstStyle/>
+                    <a:p>
+                      <a:pPr algn="ctr"/>
+                      <a:r>
+                        <a:rPr lang="tr-TR" sz="1800" dirty="0"/>
+                        <a:t>Hiçbir</a:t>
+                      </a:r>
+                    </a:p>
+                  </a:txBody>
+                  <a:tcPr/>
+                </a:tc>
+                <a:tc>
+                  <a:txBody>
+                    <a:bodyPr/>
+                    <a:lstStyle/>
+                    <a:p>
+                      <a:pPr algn="ctr"/>
+                      <a:r>
+                        <a:rPr lang="ar-AE" sz="1600" b="1" dirty="0">
+                          <a:solidFill>
+                            <a:srgbClr val="C00000"/>
+                          </a:solidFill>
+                          <a:latin typeface="Arabic Typesetting" panose="03020402040406030203" pitchFamily="66" charset="-78"/>
+                          <a:cs typeface="Arabic Typesetting" panose="03020402040406030203" pitchFamily="66" charset="-78"/>
+                        </a:rPr>
+                        <a:t>لَا</a:t>
+                      </a:r>
+                      <a:r>
+                        <a:rPr lang="ar-AE" sz="1600" b="1" dirty="0">
+                          <a:latin typeface="Arabic Typesetting" panose="03020402040406030203" pitchFamily="66" charset="-78"/>
+                          <a:cs typeface="Arabic Typesetting" panose="03020402040406030203" pitchFamily="66" charset="-78"/>
+                        </a:rPr>
+                        <a:t> </a:t>
+                      </a:r>
+                      <a:r>
+                        <a:rPr lang="ar-AE" sz="1600" b="1" dirty="0">
+                          <a:solidFill>
+                            <a:srgbClr val="0000CC"/>
+                          </a:solidFill>
+                          <a:latin typeface="Arabic Typesetting" panose="03020402040406030203" pitchFamily="66" charset="-78"/>
+                          <a:cs typeface="Arabic Typesetting" panose="03020402040406030203" pitchFamily="66" charset="-78"/>
+                        </a:rPr>
+                        <a:t>فَاعِلَ</a:t>
+                      </a:r>
+                      <a:r>
+                        <a:rPr lang="ar-AE" sz="1600" b="1" dirty="0">
+                          <a:latin typeface="Arabic Typesetting" panose="03020402040406030203" pitchFamily="66" charset="-78"/>
+                          <a:cs typeface="Arabic Typesetting" panose="03020402040406030203" pitchFamily="66" charset="-78"/>
+                        </a:rPr>
+                        <a:t> شَرٍّ </a:t>
+                      </a:r>
+                      <a:r>
+                        <a:rPr lang="ar-AE" sz="1600" b="1" dirty="0">
+                          <a:solidFill>
+                            <a:schemeClr val="accent6">
+                              <a:lumMod val="50000"/>
+                            </a:schemeClr>
+                          </a:solidFill>
+                          <a:latin typeface="Arabic Typesetting" panose="03020402040406030203" pitchFamily="66" charset="-78"/>
+                          <a:cs typeface="Arabic Typesetting" panose="03020402040406030203" pitchFamily="66" charset="-78"/>
+                        </a:rPr>
+                        <a:t>فَائِزٌ</a:t>
+                      </a:r>
+                      <a:r>
+                        <a:rPr lang="tr-TR" sz="1600" b="1" dirty="0">
+                          <a:solidFill>
+                            <a:schemeClr val="accent6">
+                              <a:lumMod val="50000"/>
+                            </a:schemeClr>
+                          </a:solidFill>
+                          <a:latin typeface="Arabic Typesetting" panose="03020402040406030203" pitchFamily="66" charset="-78"/>
+                          <a:cs typeface="Arabic Typesetting" panose="03020402040406030203" pitchFamily="66" charset="-78"/>
+                        </a:rPr>
+                        <a:t> </a:t>
+                      </a:r>
+                      <a:r>
+                        <a:rPr lang="tr-TR" sz="1600" b="1" dirty="0">
+                          <a:solidFill>
+                            <a:schemeClr val="tx1"/>
+                          </a:solidFill>
+                          <a:latin typeface="Arabic Typesetting" panose="03020402040406030203" pitchFamily="66" charset="-78"/>
+                          <a:cs typeface="Arabic Typesetting" panose="03020402040406030203" pitchFamily="66" charset="-78"/>
+                        </a:rPr>
+                        <a:t>/ Şerri yapan hiç kimse </a:t>
+                      </a:r>
+                      <a:r>
+                        <a:rPr lang="tr-TR" sz="1600" b="1" dirty="0" err="1">
+                          <a:solidFill>
+                            <a:schemeClr val="tx1"/>
+                          </a:solidFill>
+                          <a:latin typeface="Arabic Typesetting" panose="03020402040406030203" pitchFamily="66" charset="-78"/>
+                          <a:cs typeface="Arabic Typesetting" panose="03020402040406030203" pitchFamily="66" charset="-78"/>
+                        </a:rPr>
+                        <a:t>kurtulucu</a:t>
+                      </a:r>
+                      <a:r>
+                        <a:rPr lang="tr-TR" sz="1600" b="1" dirty="0">
+                          <a:solidFill>
+                            <a:schemeClr val="tx1"/>
+                          </a:solidFill>
+                          <a:latin typeface="Arabic Typesetting" panose="03020402040406030203" pitchFamily="66" charset="-78"/>
+                          <a:cs typeface="Arabic Typesetting" panose="03020402040406030203" pitchFamily="66" charset="-78"/>
+                        </a:rPr>
+                        <a:t> olmadı. </a:t>
+                      </a:r>
+                      <a:r>
+                        <a:rPr lang="tr-TR" sz="1600" b="1" u="sng" dirty="0">
+                          <a:solidFill>
+                            <a:schemeClr val="accent2">
+                              <a:lumMod val="50000"/>
+                            </a:schemeClr>
+                          </a:solidFill>
+                          <a:latin typeface="Arabic Typesetting" panose="03020402040406030203" pitchFamily="66" charset="-78"/>
+                          <a:cs typeface="Arabic Typesetting" panose="03020402040406030203" pitchFamily="66" charset="-78"/>
+                        </a:rPr>
+                        <a:t>(Cinsin </a:t>
+                      </a:r>
+                      <a:r>
+                        <a:rPr lang="tr-TR" sz="1600" b="1" u="sng" dirty="0" err="1">
+                          <a:solidFill>
+                            <a:schemeClr val="accent2">
+                              <a:lumMod val="50000"/>
+                            </a:schemeClr>
+                          </a:solidFill>
+                          <a:latin typeface="Arabic Typesetting" panose="03020402040406030203" pitchFamily="66" charset="-78"/>
+                          <a:cs typeface="Arabic Typesetting" panose="03020402040406030203" pitchFamily="66" charset="-78"/>
+                        </a:rPr>
+                        <a:t>Nefy</a:t>
+                      </a:r>
+                      <a:r>
+                        <a:rPr lang="tr-TR" sz="1600" b="1" u="sng" dirty="0">
+                          <a:solidFill>
+                            <a:schemeClr val="accent2">
+                              <a:lumMod val="50000"/>
+                            </a:schemeClr>
+                          </a:solidFill>
+                          <a:latin typeface="Arabic Typesetting" panose="03020402040406030203" pitchFamily="66" charset="-78"/>
+                          <a:cs typeface="Arabic Typesetting" panose="03020402040406030203" pitchFamily="66" charset="-78"/>
+                        </a:rPr>
+                        <a:t> Eden)</a:t>
+                      </a:r>
+                    </a:p>
+                  </a:txBody>
+                  <a:tcPr/>
+                </a:tc>
+                <a:extLst>
+                  <a:ext uri="{0D108BD9-81ED-4DB2-BD59-A6C34878D82A}">
+                    <a16:rowId xmlns:a16="http://schemas.microsoft.com/office/drawing/2014/main" val="4010344171"/>
+                  </a:ext>
+                </a:extLst>
+              </a:tr>
+            </a:tbl>
+          </a:graphicData>
+        </a:graphic>
+      </p:graphicFrame>
+      <p:grpSp>
+        <p:nvGrpSpPr>
+          <p:cNvPr id="26" name="Grup 25">
+            <a:extLst>
+              <a:ext uri="{FF2B5EF4-FFF2-40B4-BE49-F238E27FC236}">
+                <a16:creationId xmlns:a16="http://schemas.microsoft.com/office/drawing/2014/main" id="{C710EE87-673A-5270-A032-BCB969695A0A}"/>
+              </a:ext>
+            </a:extLst>
+          </p:cNvPr>
+          <p:cNvGrpSpPr/>
+          <p:nvPr/>
+        </p:nvGrpSpPr>
+        <p:grpSpPr>
+          <a:xfrm>
+            <a:off x="3690256" y="5198247"/>
+            <a:ext cx="4811485" cy="1034475"/>
+            <a:chOff x="5347062" y="5259977"/>
+            <a:chExt cx="4811485" cy="1034475"/>
+          </a:xfrm>
+        </p:grpSpPr>
+        <p:sp>
+          <p:nvSpPr>
+            <p:cNvPr id="6" name="Dikdörtgen: Köşeleri Yuvarlatılmış 5">
+              <a:extLst>
+                <a:ext uri="{FF2B5EF4-FFF2-40B4-BE49-F238E27FC236}">
+                  <a16:creationId xmlns:a16="http://schemas.microsoft.com/office/drawing/2014/main" id="{7D2E4C20-0447-30E0-F29F-D327E050685C}"/>
+                </a:ext>
+              </a:extLst>
+            </p:cNvPr>
+            <p:cNvSpPr/>
+            <p:nvPr/>
+          </p:nvSpPr>
+          <p:spPr>
+            <a:xfrm>
+              <a:off x="5347062" y="5259977"/>
+              <a:ext cx="4811485" cy="1027611"/>
+            </a:xfrm>
+            <a:prstGeom prst="roundRect">
+              <a:avLst/>
+            </a:prstGeom>
+            <a:solidFill>
+              <a:srgbClr val="156082">
+                <a:alpha val="38039"/>
+              </a:srgbClr>
+            </a:solidFill>
+          </p:spPr>
+          <p:style>
+            <a:lnRef idx="2">
+              <a:schemeClr val="accent1">
+                <a:shade val="15000"/>
+              </a:schemeClr>
+            </a:lnRef>
+            <a:fillRef idx="1">
+              <a:schemeClr val="accent1"/>
+            </a:fillRef>
+            <a:effectRef idx="0">
+              <a:schemeClr val="accent1"/>
+            </a:effectRef>
+            <a:fontRef idx="minor">
+              <a:schemeClr val="lt1"/>
+            </a:fontRef>
+          </p:style>
+          <p:txBody>
+            <a:bodyPr rtlCol="0" anchor="ctr"/>
+            <a:lstStyle/>
+            <a:p>
+              <a:pPr algn="ctr"/>
+              <a:endParaRPr lang="tr-TR" dirty="0"/>
+            </a:p>
+          </p:txBody>
+        </p:sp>
+        <p:cxnSp>
+          <p:nvCxnSpPr>
+            <p:cNvPr id="10" name="Düz Bağlayıcı 9">
+              <a:extLst>
+                <a:ext uri="{FF2B5EF4-FFF2-40B4-BE49-F238E27FC236}">
+                  <a16:creationId xmlns:a16="http://schemas.microsoft.com/office/drawing/2014/main" id="{54B335BC-75BE-B895-AA95-8A0C7D1A9158}"/>
+                </a:ext>
+              </a:extLst>
+            </p:cNvPr>
+            <p:cNvCxnSpPr>
+              <a:cxnSpLocks/>
+            </p:cNvCxnSpPr>
+            <p:nvPr/>
+          </p:nvCxnSpPr>
+          <p:spPr>
+            <a:xfrm>
+              <a:off x="8774248" y="5834526"/>
+              <a:ext cx="909683" cy="0"/>
+            </a:xfrm>
+            <a:prstGeom prst="line">
+              <a:avLst/>
+            </a:prstGeom>
+            <a:ln w="57150">
+              <a:solidFill>
+                <a:schemeClr val="tx1">
+                  <a:lumMod val="95000"/>
+                  <a:lumOff val="5000"/>
+                </a:schemeClr>
+              </a:solidFill>
+              <a:prstDash val="sysDot"/>
+            </a:ln>
+          </p:spPr>
+          <p:style>
+            <a:lnRef idx="2">
+              <a:schemeClr val="accent1"/>
+            </a:lnRef>
+            <a:fillRef idx="0">
+              <a:schemeClr val="accent1"/>
+            </a:fillRef>
+            <a:effectRef idx="1">
+              <a:schemeClr val="accent1"/>
+            </a:effectRef>
+            <a:fontRef idx="minor">
+              <a:schemeClr val="tx1"/>
+            </a:fontRef>
+          </p:style>
+        </p:cxnSp>
+        <p:cxnSp>
+          <p:nvCxnSpPr>
+            <p:cNvPr id="13" name="Düz Bağlayıcı 12">
+              <a:extLst>
+                <a:ext uri="{FF2B5EF4-FFF2-40B4-BE49-F238E27FC236}">
+                  <a16:creationId xmlns:a16="http://schemas.microsoft.com/office/drawing/2014/main" id="{34F3F4C2-B117-D13B-74F8-078083DF1478}"/>
+                </a:ext>
+              </a:extLst>
+            </p:cNvPr>
+            <p:cNvCxnSpPr>
+              <a:cxnSpLocks/>
+            </p:cNvCxnSpPr>
+            <p:nvPr/>
+          </p:nvCxnSpPr>
+          <p:spPr>
+            <a:xfrm>
+              <a:off x="7537631" y="5834526"/>
+              <a:ext cx="909683" cy="0"/>
+            </a:xfrm>
+            <a:prstGeom prst="line">
+              <a:avLst/>
+            </a:prstGeom>
+            <a:ln w="57150">
+              <a:solidFill>
+                <a:schemeClr val="tx1">
+                  <a:lumMod val="95000"/>
+                  <a:lumOff val="5000"/>
+                </a:schemeClr>
+              </a:solidFill>
+              <a:prstDash val="sysDot"/>
+            </a:ln>
+          </p:spPr>
+          <p:style>
+            <a:lnRef idx="2">
+              <a:schemeClr val="accent1"/>
+            </a:lnRef>
+            <a:fillRef idx="0">
+              <a:schemeClr val="accent1"/>
+            </a:fillRef>
+            <a:effectRef idx="1">
+              <a:schemeClr val="accent1"/>
+            </a:effectRef>
+            <a:fontRef idx="minor">
+              <a:schemeClr val="tx1"/>
+            </a:fontRef>
+          </p:style>
+        </p:cxnSp>
+        <p:cxnSp>
+          <p:nvCxnSpPr>
+            <p:cNvPr id="14" name="Düz Bağlayıcı 13">
+              <a:extLst>
+                <a:ext uri="{FF2B5EF4-FFF2-40B4-BE49-F238E27FC236}">
+                  <a16:creationId xmlns:a16="http://schemas.microsoft.com/office/drawing/2014/main" id="{EA7D8A47-4B37-E726-3821-AE46DCF8E07A}"/>
+                </a:ext>
+              </a:extLst>
+            </p:cNvPr>
+            <p:cNvCxnSpPr>
+              <a:cxnSpLocks/>
+            </p:cNvCxnSpPr>
+            <p:nvPr/>
+          </p:nvCxnSpPr>
+          <p:spPr>
+            <a:xfrm>
+              <a:off x="6095999" y="5834526"/>
+              <a:ext cx="909683" cy="0"/>
+            </a:xfrm>
+            <a:prstGeom prst="line">
+              <a:avLst/>
+            </a:prstGeom>
+            <a:ln w="57150">
+              <a:solidFill>
+                <a:schemeClr val="tx1">
+                  <a:lumMod val="95000"/>
+                  <a:lumOff val="5000"/>
+                </a:schemeClr>
+              </a:solidFill>
+              <a:prstDash val="sysDot"/>
+            </a:ln>
+          </p:spPr>
+          <p:style>
+            <a:lnRef idx="2">
+              <a:schemeClr val="accent1"/>
+            </a:lnRef>
+            <a:fillRef idx="0">
+              <a:schemeClr val="accent1"/>
+            </a:fillRef>
+            <a:effectRef idx="1">
+              <a:schemeClr val="accent1"/>
+            </a:effectRef>
+            <a:fontRef idx="minor">
+              <a:schemeClr val="tx1"/>
+            </a:fontRef>
+          </p:style>
+        </p:cxnSp>
+        <p:cxnSp>
+          <p:nvCxnSpPr>
+            <p:cNvPr id="16" name="Düz Bağlayıcı 15">
+              <a:extLst>
+                <a:ext uri="{FF2B5EF4-FFF2-40B4-BE49-F238E27FC236}">
+                  <a16:creationId xmlns:a16="http://schemas.microsoft.com/office/drawing/2014/main" id="{4914C597-8D81-E8AB-1541-9A985D6B3C17}"/>
+                </a:ext>
+              </a:extLst>
+            </p:cNvPr>
+            <p:cNvCxnSpPr>
+              <a:cxnSpLocks/>
+            </p:cNvCxnSpPr>
+            <p:nvPr/>
+          </p:nvCxnSpPr>
+          <p:spPr>
+            <a:xfrm>
+              <a:off x="8682808" y="5926965"/>
+              <a:ext cx="1062083" cy="0"/>
+            </a:xfrm>
+            <a:prstGeom prst="line">
+              <a:avLst/>
+            </a:prstGeom>
+          </p:spPr>
+          <p:style>
+            <a:lnRef idx="2">
+              <a:schemeClr val="accent1"/>
+            </a:lnRef>
+            <a:fillRef idx="0">
+              <a:schemeClr val="accent1"/>
+            </a:fillRef>
+            <a:effectRef idx="1">
+              <a:schemeClr val="accent1"/>
+            </a:effectRef>
+            <a:fontRef idx="minor">
+              <a:schemeClr val="tx1"/>
+            </a:fontRef>
+          </p:style>
+        </p:cxnSp>
+        <p:sp>
+          <p:nvSpPr>
+            <p:cNvPr id="18" name="Metin kutusu 17">
+              <a:extLst>
+                <a:ext uri="{FF2B5EF4-FFF2-40B4-BE49-F238E27FC236}">
+                  <a16:creationId xmlns:a16="http://schemas.microsoft.com/office/drawing/2014/main" id="{AAEF7D8B-3751-A359-3592-43BB2EEDE25A}"/>
+                </a:ext>
+              </a:extLst>
+            </p:cNvPr>
+            <p:cNvSpPr txBox="1"/>
+            <p:nvPr/>
+          </p:nvSpPr>
+          <p:spPr>
+            <a:xfrm>
+              <a:off x="8848089" y="5898832"/>
+              <a:ext cx="678391" cy="369332"/>
+            </a:xfrm>
+            <a:prstGeom prst="rect">
+              <a:avLst/>
+            </a:prstGeom>
+            <a:noFill/>
+          </p:spPr>
+          <p:txBody>
+            <a:bodyPr wrap="none" rtlCol="0">
+              <a:spAutoFit/>
+            </a:bodyPr>
+            <a:lstStyle/>
+            <a:p>
+              <a:r>
+                <a:rPr lang="tr-TR" dirty="0">
+                  <a:solidFill>
+                    <a:srgbClr val="FF0000"/>
+                  </a:solidFill>
+                </a:rPr>
+                <a:t>AMİL</a:t>
+              </a:r>
+            </a:p>
+          </p:txBody>
+        </p:sp>
+        <p:sp>
+          <p:nvSpPr>
+            <p:cNvPr id="19" name="Metin kutusu 18">
+              <a:extLst>
+                <a:ext uri="{FF2B5EF4-FFF2-40B4-BE49-F238E27FC236}">
+                  <a16:creationId xmlns:a16="http://schemas.microsoft.com/office/drawing/2014/main" id="{3A52134C-2DF9-E525-0458-CA2866B3D0B4}"/>
+                </a:ext>
+              </a:extLst>
+            </p:cNvPr>
+            <p:cNvSpPr txBox="1"/>
+            <p:nvPr/>
+          </p:nvSpPr>
+          <p:spPr>
+            <a:xfrm>
+              <a:off x="7537631" y="5923393"/>
+              <a:ext cx="607859" cy="369332"/>
+            </a:xfrm>
+            <a:prstGeom prst="rect">
+              <a:avLst/>
+            </a:prstGeom>
+            <a:noFill/>
+          </p:spPr>
+          <p:txBody>
+            <a:bodyPr wrap="none" rtlCol="0">
+              <a:spAutoFit/>
+            </a:bodyPr>
+            <a:lstStyle/>
+            <a:p>
+              <a:r>
+                <a:rPr lang="tr-TR" dirty="0">
+                  <a:solidFill>
+                    <a:srgbClr val="0000CC"/>
+                  </a:solidFill>
+                </a:rPr>
+                <a:t>İsmi</a:t>
+              </a:r>
+            </a:p>
+          </p:txBody>
+        </p:sp>
+        <p:cxnSp>
+          <p:nvCxnSpPr>
+            <p:cNvPr id="20" name="Düz Bağlayıcı 19">
+              <a:extLst>
+                <a:ext uri="{FF2B5EF4-FFF2-40B4-BE49-F238E27FC236}">
+                  <a16:creationId xmlns:a16="http://schemas.microsoft.com/office/drawing/2014/main" id="{7120F408-8A67-1554-9455-83827E9F4530}"/>
+                </a:ext>
+              </a:extLst>
+            </p:cNvPr>
+            <p:cNvCxnSpPr>
+              <a:cxnSpLocks/>
+            </p:cNvCxnSpPr>
+            <p:nvPr/>
+          </p:nvCxnSpPr>
+          <p:spPr>
+            <a:xfrm>
+              <a:off x="7461430" y="5923393"/>
+              <a:ext cx="1062083" cy="0"/>
+            </a:xfrm>
+            <a:prstGeom prst="line">
+              <a:avLst/>
+            </a:prstGeom>
+          </p:spPr>
+          <p:style>
+            <a:lnRef idx="2">
+              <a:schemeClr val="accent1"/>
+            </a:lnRef>
+            <a:fillRef idx="0">
+              <a:schemeClr val="accent1"/>
+            </a:fillRef>
+            <a:effectRef idx="1">
+              <a:schemeClr val="accent1"/>
+            </a:effectRef>
+            <a:fontRef idx="minor">
+              <a:schemeClr val="tx1"/>
+            </a:fontRef>
+          </p:style>
+        </p:cxnSp>
+        <p:sp>
+          <p:nvSpPr>
+            <p:cNvPr id="21" name="Metin kutusu 20">
+              <a:extLst>
+                <a:ext uri="{FF2B5EF4-FFF2-40B4-BE49-F238E27FC236}">
+                  <a16:creationId xmlns:a16="http://schemas.microsoft.com/office/drawing/2014/main" id="{4DB9819B-6F8F-25E8-EA01-12F8FC009ACF}"/>
+                </a:ext>
+              </a:extLst>
+            </p:cNvPr>
+            <p:cNvSpPr txBox="1"/>
+            <p:nvPr/>
+          </p:nvSpPr>
+          <p:spPr>
+            <a:xfrm>
+              <a:off x="6095999" y="5925120"/>
+              <a:ext cx="854721" cy="369332"/>
+            </a:xfrm>
+            <a:prstGeom prst="rect">
+              <a:avLst/>
+            </a:prstGeom>
+            <a:noFill/>
+          </p:spPr>
+          <p:txBody>
+            <a:bodyPr wrap="none" rtlCol="0">
+              <a:spAutoFit/>
+            </a:bodyPr>
+            <a:lstStyle/>
+            <a:p>
+              <a:r>
+                <a:rPr lang="tr-TR" dirty="0"/>
+                <a:t>Haberi</a:t>
+              </a:r>
+            </a:p>
+          </p:txBody>
+        </p:sp>
+        <p:cxnSp>
+          <p:nvCxnSpPr>
+            <p:cNvPr id="22" name="Düz Bağlayıcı 21">
+              <a:extLst>
+                <a:ext uri="{FF2B5EF4-FFF2-40B4-BE49-F238E27FC236}">
+                  <a16:creationId xmlns:a16="http://schemas.microsoft.com/office/drawing/2014/main" id="{5DC911A5-27EB-C920-4711-36CEE11BE77B}"/>
+                </a:ext>
+              </a:extLst>
+            </p:cNvPr>
+            <p:cNvCxnSpPr>
+              <a:cxnSpLocks/>
+            </p:cNvCxnSpPr>
+            <p:nvPr/>
+          </p:nvCxnSpPr>
+          <p:spPr>
+            <a:xfrm>
+              <a:off x="6019798" y="5925120"/>
+              <a:ext cx="1062083" cy="0"/>
+            </a:xfrm>
+            <a:prstGeom prst="line">
+              <a:avLst/>
+            </a:prstGeom>
+          </p:spPr>
+          <p:style>
+            <a:lnRef idx="2">
+              <a:schemeClr val="accent1"/>
+            </a:lnRef>
+            <a:fillRef idx="0">
+              <a:schemeClr val="accent1"/>
+            </a:fillRef>
+            <a:effectRef idx="1">
+              <a:schemeClr val="accent1"/>
+            </a:effectRef>
+            <a:fontRef idx="minor">
+              <a:schemeClr val="tx1"/>
+            </a:fontRef>
+          </p:style>
+        </p:cxnSp>
+        <p:sp>
+          <p:nvSpPr>
+            <p:cNvPr id="23" name="Metin kutusu 22">
+              <a:extLst>
+                <a:ext uri="{FF2B5EF4-FFF2-40B4-BE49-F238E27FC236}">
+                  <a16:creationId xmlns:a16="http://schemas.microsoft.com/office/drawing/2014/main" id="{6A0DFB13-2457-0871-2E76-D73848627200}"/>
+                </a:ext>
+              </a:extLst>
+            </p:cNvPr>
+            <p:cNvSpPr txBox="1"/>
+            <p:nvPr/>
+          </p:nvSpPr>
+          <p:spPr>
+            <a:xfrm>
+              <a:off x="7407830" y="5417295"/>
+              <a:ext cx="435191" cy="461665"/>
+            </a:xfrm>
+            <a:prstGeom prst="rect">
+              <a:avLst/>
+            </a:prstGeom>
+            <a:noFill/>
+          </p:spPr>
+          <p:txBody>
+            <a:bodyPr wrap="square" rtlCol="0">
+              <a:spAutoFit/>
+            </a:bodyPr>
+            <a:lstStyle/>
+            <a:p>
+              <a:r>
+                <a:rPr lang="ar-AE" sz="2400" b="1" dirty="0">
+                  <a:latin typeface="Amiri Quran" panose="00000500000000000000" pitchFamily="2" charset="-78"/>
+                  <a:cs typeface="Amiri Quran" panose="00000500000000000000" pitchFamily="2" charset="-78"/>
+                </a:rPr>
+                <a:t>ً</a:t>
+              </a:r>
+              <a:endParaRPr lang="tr-TR" sz="2400" b="1" dirty="0">
+                <a:latin typeface="Amiri Quran" panose="00000500000000000000" pitchFamily="2" charset="-78"/>
+                <a:cs typeface="Amiri Quran" panose="00000500000000000000" pitchFamily="2" charset="-78"/>
+              </a:endParaRPr>
+            </a:p>
+          </p:txBody>
+        </p:sp>
+        <p:sp>
+          <p:nvSpPr>
+            <p:cNvPr id="24" name="Metin kutusu 23">
+              <a:extLst>
+                <a:ext uri="{FF2B5EF4-FFF2-40B4-BE49-F238E27FC236}">
+                  <a16:creationId xmlns:a16="http://schemas.microsoft.com/office/drawing/2014/main" id="{8FAB844F-4D13-E1EA-A687-13F47F27F642}"/>
+                </a:ext>
+              </a:extLst>
+            </p:cNvPr>
+            <p:cNvSpPr txBox="1"/>
+            <p:nvPr/>
+          </p:nvSpPr>
+          <p:spPr>
+            <a:xfrm>
+              <a:off x="5949223" y="5413857"/>
+              <a:ext cx="435191" cy="461665"/>
+            </a:xfrm>
+            <a:prstGeom prst="rect">
+              <a:avLst/>
+            </a:prstGeom>
+            <a:noFill/>
+          </p:spPr>
+          <p:txBody>
+            <a:bodyPr wrap="square" rtlCol="0">
+              <a:spAutoFit/>
+            </a:bodyPr>
+            <a:lstStyle/>
+            <a:p>
+              <a:r>
+                <a:rPr lang="ar-AE" sz="2400" b="1" dirty="0">
+                  <a:latin typeface="Amiri Quran" panose="00000500000000000000" pitchFamily="2" charset="-78"/>
+                  <a:cs typeface="Amiri Quran" panose="00000500000000000000" pitchFamily="2" charset="-78"/>
+                </a:rPr>
+                <a:t>ٌ</a:t>
+              </a:r>
+              <a:endParaRPr lang="tr-TR" sz="2400" b="1" dirty="0">
+                <a:latin typeface="Amiri Quran" panose="00000500000000000000" pitchFamily="2" charset="-78"/>
+                <a:cs typeface="Amiri Quran" panose="00000500000000000000" pitchFamily="2" charset="-78"/>
+              </a:endParaRPr>
+            </a:p>
+          </p:txBody>
+        </p:sp>
+      </p:grpSp>
     </p:spTree>
     <p:extLst>
       <p:ext uri="{BB962C8B-B14F-4D97-AF65-F5344CB8AC3E}">

</xml_diff>

<commit_message>
Amil nevi3 ve nevi4 eklendi
</commit_message>
<xml_diff>
--- a/Nahiv/Avamil/Amil.pptx
+++ b/Nahiv/Avamil/Amil.pptx
@@ -5,7 +5,7 @@
     <p:sldMasterId id="2147483648" r:id="rId1"/>
   </p:sldMasterIdLst>
   <p:notesMasterIdLst>
-    <p:notesMasterId r:id="rId7"/>
+    <p:notesMasterId r:id="rId8"/>
   </p:notesMasterIdLst>
   <p:sldIdLst>
     <p:sldId id="256" r:id="rId2"/>
@@ -13,6 +13,7 @@
     <p:sldId id="258" r:id="rId4"/>
     <p:sldId id="259" r:id="rId5"/>
     <p:sldId id="260" r:id="rId6"/>
+    <p:sldId id="261" r:id="rId7"/>
   </p:sldIdLst>
   <p:sldSz cx="12192000" cy="6858000"/>
   <p:notesSz cx="6858000" cy="9144000"/>
@@ -1114,7 +1115,7 @@
           <a:p>
             <a:fld id="{FA2DF9BE-F4DC-4902-9C94-926DFEDD4A7A}" type="datetimeFigureOut">
               <a:rPr lang="tr-TR" smtClean="0"/>
-              <a:t>13.10.2026</a:t>
+              <a:t>18.10.2026</a:t>
             </a:fld>
             <a:endParaRPr lang="tr-TR"/>
           </a:p>
@@ -1633,6 +1634,90 @@
 </p:notes>
 </file>
 
+<file path=ppt/notesSlides/notesSlide4.xml><?xml version="1.0" encoding="utf-8"?>
+<p:notes xmlns:a="http://schemas.openxmlformats.org/drawingml/2006/main" xmlns:r="http://schemas.openxmlformats.org/officeDocument/2006/relationships" xmlns:p="http://schemas.openxmlformats.org/presentationml/2006/main">
+  <p:cSld>
+    <p:spTree>
+      <p:nvGrpSpPr>
+        <p:cNvPr id="1" name=""/>
+        <p:cNvGrpSpPr/>
+        <p:nvPr/>
+      </p:nvGrpSpPr>
+      <p:grpSpPr>
+        <a:xfrm>
+          <a:off x="0" y="0"/>
+          <a:ext cx="0" cy="0"/>
+          <a:chOff x="0" y="0"/>
+          <a:chExt cx="0" cy="0"/>
+        </a:xfrm>
+      </p:grpSpPr>
+      <p:sp>
+        <p:nvSpPr>
+          <p:cNvPr id="2" name="Slayt Resmi Yer Tutucusu 1"/>
+          <p:cNvSpPr>
+            <a:spLocks noGrp="1" noRot="1" noChangeAspect="1"/>
+          </p:cNvSpPr>
+          <p:nvPr>
+            <p:ph type="sldImg"/>
+          </p:nvPr>
+        </p:nvSpPr>
+        <p:spPr/>
+      </p:sp>
+      <p:sp>
+        <p:nvSpPr>
+          <p:cNvPr id="3" name="Not Yer Tutucusu 2"/>
+          <p:cNvSpPr>
+            <a:spLocks noGrp="1"/>
+          </p:cNvSpPr>
+          <p:nvPr>
+            <p:ph type="body" idx="1"/>
+          </p:nvPr>
+        </p:nvSpPr>
+        <p:spPr/>
+        <p:txBody>
+          <a:bodyPr/>
+          <a:lstStyle/>
+          <a:p>
+            <a:endParaRPr lang="tr-TR" dirty="0"/>
+          </a:p>
+        </p:txBody>
+      </p:sp>
+      <p:sp>
+        <p:nvSpPr>
+          <p:cNvPr id="4" name="Slayt Numarası Yer Tutucusu 3"/>
+          <p:cNvSpPr>
+            <a:spLocks noGrp="1"/>
+          </p:cNvSpPr>
+          <p:nvPr>
+            <p:ph type="sldNum" sz="quarter" idx="5"/>
+          </p:nvPr>
+        </p:nvSpPr>
+        <p:spPr/>
+        <p:txBody>
+          <a:bodyPr/>
+          <a:lstStyle/>
+          <a:p>
+            <a:fld id="{638F92E4-635E-4B69-8547-655F7F9D76B7}" type="slidenum">
+              <a:rPr lang="tr-TR" smtClean="0"/>
+              <a:t>6</a:t>
+            </a:fld>
+            <a:endParaRPr lang="tr-TR"/>
+          </a:p>
+        </p:txBody>
+      </p:sp>
+    </p:spTree>
+    <p:extLst>
+      <p:ext uri="{BB962C8B-B14F-4D97-AF65-F5344CB8AC3E}">
+        <p14:creationId xmlns:p14="http://schemas.microsoft.com/office/powerpoint/2010/main" val="2755003743"/>
+      </p:ext>
+    </p:extLst>
+  </p:cSld>
+  <p:clrMapOvr>
+    <a:masterClrMapping/>
+  </p:clrMapOvr>
+</p:notes>
+</file>
+
 <file path=ppt/slideLayouts/slideLayout1.xml><?xml version="1.0" encoding="utf-8"?>
 <p:sldLayout xmlns:a="http://schemas.openxmlformats.org/drawingml/2006/main" xmlns:r="http://schemas.openxmlformats.org/officeDocument/2006/relationships" xmlns:p="http://schemas.openxmlformats.org/presentationml/2006/main" type="title" preserve="1">
   <p:cSld name="Başlık Slaydı">
@@ -1780,7 +1865,7 @@
           <a:p>
             <a:fld id="{47B4E739-70D6-40BD-B9BF-46BF9FC7432A}" type="datetimeFigureOut">
               <a:rPr lang="tr-TR" smtClean="0"/>
-              <a:t>13.10.2026</a:t>
+              <a:t>18.10.2026</a:t>
             </a:fld>
             <a:endParaRPr lang="tr-TR"/>
           </a:p>
@@ -1978,7 +2063,7 @@
           <a:p>
             <a:fld id="{47B4E739-70D6-40BD-B9BF-46BF9FC7432A}" type="datetimeFigureOut">
               <a:rPr lang="tr-TR" smtClean="0"/>
-              <a:t>13.10.2026</a:t>
+              <a:t>18.10.2026</a:t>
             </a:fld>
             <a:endParaRPr lang="tr-TR"/>
           </a:p>
@@ -2186,7 +2271,7 @@
           <a:p>
             <a:fld id="{47B4E739-70D6-40BD-B9BF-46BF9FC7432A}" type="datetimeFigureOut">
               <a:rPr lang="tr-TR" smtClean="0"/>
-              <a:t>13.10.2026</a:t>
+              <a:t>18.10.2026</a:t>
             </a:fld>
             <a:endParaRPr lang="tr-TR"/>
           </a:p>
@@ -2384,7 +2469,7 @@
           <a:p>
             <a:fld id="{47B4E739-70D6-40BD-B9BF-46BF9FC7432A}" type="datetimeFigureOut">
               <a:rPr lang="tr-TR" smtClean="0"/>
-              <a:t>13.10.2026</a:t>
+              <a:t>18.10.2026</a:t>
             </a:fld>
             <a:endParaRPr lang="tr-TR"/>
           </a:p>
@@ -2659,7 +2744,7 @@
           <a:p>
             <a:fld id="{47B4E739-70D6-40BD-B9BF-46BF9FC7432A}" type="datetimeFigureOut">
               <a:rPr lang="tr-TR" smtClean="0"/>
-              <a:t>13.10.2026</a:t>
+              <a:t>18.10.2026</a:t>
             </a:fld>
             <a:endParaRPr lang="tr-TR"/>
           </a:p>
@@ -2924,7 +3009,7 @@
           <a:p>
             <a:fld id="{47B4E739-70D6-40BD-B9BF-46BF9FC7432A}" type="datetimeFigureOut">
               <a:rPr lang="tr-TR" smtClean="0"/>
-              <a:t>13.10.2026</a:t>
+              <a:t>18.10.2026</a:t>
             </a:fld>
             <a:endParaRPr lang="tr-TR"/>
           </a:p>
@@ -3336,7 +3421,7 @@
           <a:p>
             <a:fld id="{47B4E739-70D6-40BD-B9BF-46BF9FC7432A}" type="datetimeFigureOut">
               <a:rPr lang="tr-TR" smtClean="0"/>
-              <a:t>13.10.2026</a:t>
+              <a:t>18.10.2026</a:t>
             </a:fld>
             <a:endParaRPr lang="tr-TR"/>
           </a:p>
@@ -3477,7 +3562,7 @@
           <a:p>
             <a:fld id="{47B4E739-70D6-40BD-B9BF-46BF9FC7432A}" type="datetimeFigureOut">
               <a:rPr lang="tr-TR" smtClean="0"/>
-              <a:t>13.10.2026</a:t>
+              <a:t>18.10.2026</a:t>
             </a:fld>
             <a:endParaRPr lang="tr-TR"/>
           </a:p>
@@ -3590,7 +3675,7 @@
           <a:p>
             <a:fld id="{47B4E739-70D6-40BD-B9BF-46BF9FC7432A}" type="datetimeFigureOut">
               <a:rPr lang="tr-TR" smtClean="0"/>
-              <a:t>13.10.2026</a:t>
+              <a:t>18.10.2026</a:t>
             </a:fld>
             <a:endParaRPr lang="tr-TR"/>
           </a:p>
@@ -3901,7 +3986,7 @@
           <a:p>
             <a:fld id="{47B4E739-70D6-40BD-B9BF-46BF9FC7432A}" type="datetimeFigureOut">
               <a:rPr lang="tr-TR" smtClean="0"/>
-              <a:t>13.10.2026</a:t>
+              <a:t>18.10.2026</a:t>
             </a:fld>
             <a:endParaRPr lang="tr-TR"/>
           </a:p>
@@ -4189,7 +4274,7 @@
           <a:p>
             <a:fld id="{47B4E739-70D6-40BD-B9BF-46BF9FC7432A}" type="datetimeFigureOut">
               <a:rPr lang="tr-TR" smtClean="0"/>
-              <a:t>13.10.2026</a:t>
+              <a:t>18.10.2026</a:t>
             </a:fld>
             <a:endParaRPr lang="tr-TR"/>
           </a:p>
@@ -4430,7 +4515,7 @@
           <a:p>
             <a:fld id="{47B4E739-70D6-40BD-B9BF-46BF9FC7432A}" type="datetimeFigureOut">
               <a:rPr lang="tr-TR" smtClean="0"/>
-              <a:t>13.10.2026</a:t>
+              <a:t>18.10.2026</a:t>
             </a:fld>
             <a:endParaRPr lang="tr-TR"/>
           </a:p>
@@ -9890,8 +9975,8 @@
         </p:nvSpPr>
         <p:spPr>
           <a:xfrm>
-            <a:off x="9137650" y="120760"/>
-            <a:ext cx="2728632" cy="400110"/>
+            <a:off x="8027125" y="120760"/>
+            <a:ext cx="4089581" cy="400110"/>
           </a:xfrm>
           <a:prstGeom prst="rect">
             <a:avLst/>
@@ -9914,7 +9999,7 @@
                 <a:latin typeface="Alef" panose="00000500000000000000" pitchFamily="2" charset="-79"/>
                 <a:cs typeface="Alef" panose="00000500000000000000" pitchFamily="2" charset="-79"/>
               </a:rPr>
-              <a:t>İsmi </a:t>
+              <a:t>İsmini </a:t>
             </a:r>
             <a:r>
               <a:rPr lang="tr-TR" sz="2000" i="1" u="sng" dirty="0" err="1">
@@ -9938,7 +10023,7 @@
                 <a:latin typeface="Alef" panose="00000500000000000000" pitchFamily="2" charset="-79"/>
                 <a:cs typeface="Alef" panose="00000500000000000000" pitchFamily="2" charset="-79"/>
               </a:rPr>
-              <a:t>, Haberi </a:t>
+              <a:t>, Haberini </a:t>
             </a:r>
             <a:r>
               <a:rPr lang="tr-TR" sz="2000" i="1" u="sng" dirty="0" err="1">
@@ -9952,15 +10037,18 @@
               </a:rPr>
               <a:t>Ref</a:t>
             </a:r>
-            <a:endParaRPr lang="tr-TR" sz="2000" i="1" u="sng" dirty="0">
-              <a:solidFill>
-                <a:schemeClr val="bg1">
-                  <a:lumMod val="95000"/>
-                </a:schemeClr>
-              </a:solidFill>
-              <a:latin typeface="Alef" panose="00000500000000000000" pitchFamily="2" charset="-79"/>
-              <a:cs typeface="Alef" panose="00000500000000000000" pitchFamily="2" charset="-79"/>
-            </a:endParaRPr>
+            <a:r>
+              <a:rPr lang="tr-TR" sz="2000" i="1" u="sng" dirty="0">
+                <a:solidFill>
+                  <a:schemeClr val="bg1">
+                    <a:lumMod val="95000"/>
+                  </a:schemeClr>
+                </a:solidFill>
+                <a:latin typeface="Alef" panose="00000500000000000000" pitchFamily="2" charset="-79"/>
+                <a:cs typeface="Alef" panose="00000500000000000000" pitchFamily="2" charset="-79"/>
+              </a:rPr>
+              <a:t> Edenler</a:t>
+            </a:r>
           </a:p>
         </p:txBody>
       </p:sp>
@@ -12019,10 +12107,10 @@
       </p:sp>
       <p:sp>
         <p:nvSpPr>
-          <p:cNvPr id="4" name="Metin kutusu 3">
+          <p:cNvPr id="3" name="Metin kutusu 2">
             <a:extLst>
               <a:ext uri="{FF2B5EF4-FFF2-40B4-BE49-F238E27FC236}">
-                <a16:creationId xmlns:a16="http://schemas.microsoft.com/office/drawing/2014/main" id="{9668639A-0B97-AD1E-43FA-28EF8958806C}"/>
+                <a16:creationId xmlns:a16="http://schemas.microsoft.com/office/drawing/2014/main" id="{46884D15-E418-F484-DBD1-B3020DA73FE4}"/>
               </a:ext>
             </a:extLst>
           </p:cNvPr>
@@ -12031,8 +12119,8 @@
         </p:nvSpPr>
         <p:spPr>
           <a:xfrm>
-            <a:off x="9137650" y="120760"/>
-            <a:ext cx="2728632" cy="400110"/>
+            <a:off x="7896497" y="120760"/>
+            <a:ext cx="4089581" cy="400110"/>
           </a:xfrm>
           <a:prstGeom prst="rect">
             <a:avLst/>
@@ -12055,7 +12143,7 @@
                 <a:latin typeface="Alef" panose="00000500000000000000" pitchFamily="2" charset="-79"/>
                 <a:cs typeface="Alef" panose="00000500000000000000" pitchFamily="2" charset="-79"/>
               </a:rPr>
-              <a:t>İsmi </a:t>
+              <a:t>İsmini </a:t>
             </a:r>
             <a:r>
               <a:rPr lang="tr-TR" sz="2000" i="1" u="sng" dirty="0" err="1">
@@ -12079,7 +12167,7 @@
                 <a:latin typeface="Alef" panose="00000500000000000000" pitchFamily="2" charset="-79"/>
                 <a:cs typeface="Alef" panose="00000500000000000000" pitchFamily="2" charset="-79"/>
               </a:rPr>
-              <a:t>, Haberi </a:t>
+              <a:t>, Haberini </a:t>
             </a:r>
             <a:r>
               <a:rPr lang="tr-TR" sz="2000" i="1" u="sng" dirty="0" err="1">
@@ -12093,22 +12181,1442 @@
               </a:rPr>
               <a:t>Nasb</a:t>
             </a:r>
-            <a:endParaRPr lang="tr-TR" sz="2000" i="1" u="sng" dirty="0">
+            <a:r>
+              <a:rPr lang="tr-TR" sz="2000" i="1" u="sng" dirty="0">
+                <a:solidFill>
+                  <a:schemeClr val="bg1">
+                    <a:lumMod val="95000"/>
+                  </a:schemeClr>
+                </a:solidFill>
+                <a:latin typeface="Alef" panose="00000500000000000000" pitchFamily="2" charset="-79"/>
+                <a:cs typeface="Alef" panose="00000500000000000000" pitchFamily="2" charset="-79"/>
+              </a:rPr>
+              <a:t> Edenler</a:t>
+            </a:r>
+          </a:p>
+        </p:txBody>
+      </p:sp>
+      <p:sp>
+        <p:nvSpPr>
+          <p:cNvPr id="6" name="Metin kutusu 5">
+            <a:extLst>
+              <a:ext uri="{FF2B5EF4-FFF2-40B4-BE49-F238E27FC236}">
+                <a16:creationId xmlns:a16="http://schemas.microsoft.com/office/drawing/2014/main" id="{D508230F-F398-777E-E497-0077A502A310}"/>
+              </a:ext>
+            </a:extLst>
+          </p:cNvPr>
+          <p:cNvSpPr txBox="1"/>
+          <p:nvPr/>
+        </p:nvSpPr>
+        <p:spPr>
+          <a:xfrm>
+            <a:off x="4089616" y="766354"/>
+            <a:ext cx="4012765" cy="523220"/>
+          </a:xfrm>
+          <a:prstGeom prst="rect">
+            <a:avLst/>
+          </a:prstGeom>
+          <a:noFill/>
+        </p:spPr>
+        <p:txBody>
+          <a:bodyPr wrap="none" rtlCol="0">
+            <a:spAutoFit/>
+          </a:bodyPr>
+          <a:lstStyle/>
+          <a:p>
+            <a:r>
+              <a:rPr lang="ar-AE" sz="2800" b="1" dirty="0">
+                <a:solidFill>
+                  <a:srgbClr val="FF0000"/>
+                </a:solidFill>
+              </a:rPr>
+              <a:t>لَيْسَ</a:t>
+            </a:r>
+            <a:r>
+              <a:rPr lang="tr-TR" sz="2800" b="1" dirty="0"/>
+              <a:t>’ye BENZEYEN </a:t>
+            </a:r>
+            <a:r>
+              <a:rPr lang="ar-AE" sz="2800" b="1" u="sng" dirty="0">
+                <a:solidFill>
+                  <a:schemeClr val="tx2">
+                    <a:lumMod val="90000"/>
+                    <a:lumOff val="10000"/>
+                  </a:schemeClr>
+                </a:solidFill>
+              </a:rPr>
+              <a:t>مَا</a:t>
+            </a:r>
+            <a:r>
+              <a:rPr lang="tr-TR" sz="2800" b="1" dirty="0"/>
+              <a:t> ve </a:t>
+            </a:r>
+            <a:r>
+              <a:rPr lang="ar-AE" sz="2800" b="1" u="sng" dirty="0">
+                <a:solidFill>
+                  <a:schemeClr val="tx2">
+                    <a:lumMod val="90000"/>
+                    <a:lumOff val="10000"/>
+                  </a:schemeClr>
+                </a:solidFill>
+              </a:rPr>
+              <a:t>لَا</a:t>
+            </a:r>
+            <a:endParaRPr lang="tr-TR" sz="2800" b="1" u="sng" dirty="0">
               <a:solidFill>
-                <a:schemeClr val="bg1">
-                  <a:lumMod val="95000"/>
+                <a:schemeClr val="tx2">
+                  <a:lumMod val="90000"/>
+                  <a:lumOff val="10000"/>
                 </a:schemeClr>
               </a:solidFill>
-              <a:latin typeface="Alef" panose="00000500000000000000" pitchFamily="2" charset="-79"/>
-              <a:cs typeface="Alef" panose="00000500000000000000" pitchFamily="2" charset="-79"/>
             </a:endParaRPr>
           </a:p>
         </p:txBody>
       </p:sp>
+      <p:sp>
+        <p:nvSpPr>
+          <p:cNvPr id="7" name="Metin kutusu 6">
+            <a:extLst>
+              <a:ext uri="{FF2B5EF4-FFF2-40B4-BE49-F238E27FC236}">
+                <a16:creationId xmlns:a16="http://schemas.microsoft.com/office/drawing/2014/main" id="{C1497EB9-E1C8-4AF4-66DC-10CB48EF0224}"/>
+              </a:ext>
+            </a:extLst>
+          </p:cNvPr>
+          <p:cNvSpPr txBox="1"/>
+          <p:nvPr/>
+        </p:nvSpPr>
+        <p:spPr>
+          <a:xfrm>
+            <a:off x="59266" y="1357231"/>
+            <a:ext cx="12073463" cy="646331"/>
+          </a:xfrm>
+          <a:prstGeom prst="rect">
+            <a:avLst/>
+          </a:prstGeom>
+          <a:noFill/>
+        </p:spPr>
+        <p:txBody>
+          <a:bodyPr wrap="square" rtlCol="0">
+            <a:spAutoFit/>
+          </a:bodyPr>
+          <a:lstStyle/>
+          <a:p>
+            <a:r>
+              <a:rPr lang="tr-TR" dirty="0"/>
+              <a:t>Bu iki harf </a:t>
+            </a:r>
+            <a:r>
+              <a:rPr lang="ar-AE" u="sng" dirty="0">
+                <a:solidFill>
+                  <a:srgbClr val="C00000"/>
+                </a:solidFill>
+              </a:rPr>
+              <a:t>لَيْسَ</a:t>
+            </a:r>
+            <a:r>
+              <a:rPr lang="tr-TR" dirty="0"/>
+              <a:t> gibi olumsuzluk ifade etmesi ve asılda </a:t>
+            </a:r>
+            <a:r>
+              <a:rPr lang="tr-TR" dirty="0" err="1"/>
+              <a:t>mübteda</a:t>
+            </a:r>
+            <a:r>
+              <a:rPr lang="tr-TR" dirty="0"/>
+              <a:t> haber üzerine dahil olmasından dolayı </a:t>
+            </a:r>
+            <a:r>
+              <a:rPr lang="ar-AE" u="sng" dirty="0">
+                <a:solidFill>
+                  <a:srgbClr val="C00000"/>
+                </a:solidFill>
+              </a:rPr>
+              <a:t>لَيْسَ</a:t>
+            </a:r>
+            <a:r>
+              <a:rPr lang="tr-TR" dirty="0"/>
+              <a:t>’ ye benzemektedir.</a:t>
+            </a:r>
+          </a:p>
+        </p:txBody>
+      </p:sp>
+      <p:sp>
+        <p:nvSpPr>
+          <p:cNvPr id="8" name="Metin kutusu 7">
+            <a:extLst>
+              <a:ext uri="{FF2B5EF4-FFF2-40B4-BE49-F238E27FC236}">
+                <a16:creationId xmlns:a16="http://schemas.microsoft.com/office/drawing/2014/main" id="{DAAA9A43-7C0C-B223-1DBD-07EE5CDAB43D}"/>
+              </a:ext>
+            </a:extLst>
+          </p:cNvPr>
+          <p:cNvSpPr txBox="1"/>
+          <p:nvPr/>
+        </p:nvSpPr>
+        <p:spPr>
+          <a:xfrm>
+            <a:off x="576072" y="2071219"/>
+            <a:ext cx="2570960" cy="461665"/>
+          </a:xfrm>
+          <a:prstGeom prst="rect">
+            <a:avLst/>
+          </a:prstGeom>
+          <a:noFill/>
+        </p:spPr>
+        <p:txBody>
+          <a:bodyPr wrap="none" rtlCol="0">
+            <a:spAutoFit/>
+          </a:bodyPr>
+          <a:lstStyle/>
+          <a:p>
+            <a:r>
+              <a:rPr lang="ar-AE" sz="2400" b="1" dirty="0">
+                <a:solidFill>
+                  <a:srgbClr val="C00000"/>
+                </a:solidFill>
+              </a:rPr>
+              <a:t>مَا</a:t>
+            </a:r>
+            <a:r>
+              <a:rPr lang="tr-TR" sz="2400" b="1" dirty="0">
+                <a:solidFill>
+                  <a:srgbClr val="C00000"/>
+                </a:solidFill>
+              </a:rPr>
+              <a:t> Harfinin Misali:</a:t>
+            </a:r>
+          </a:p>
+        </p:txBody>
+      </p:sp>
+      <p:sp>
+        <p:nvSpPr>
+          <p:cNvPr id="10" name="Metin kutusu 9">
+            <a:extLst>
+              <a:ext uri="{FF2B5EF4-FFF2-40B4-BE49-F238E27FC236}">
+                <a16:creationId xmlns:a16="http://schemas.microsoft.com/office/drawing/2014/main" id="{1D5D7901-E4E8-DB0F-C7E8-C2F33738574A}"/>
+              </a:ext>
+            </a:extLst>
+          </p:cNvPr>
+          <p:cNvSpPr txBox="1"/>
+          <p:nvPr/>
+        </p:nvSpPr>
+        <p:spPr>
+          <a:xfrm>
+            <a:off x="1861552" y="2532884"/>
+            <a:ext cx="2611612" cy="461665"/>
+          </a:xfrm>
+          <a:prstGeom prst="rect">
+            <a:avLst/>
+          </a:prstGeom>
+          <a:noFill/>
+        </p:spPr>
+        <p:txBody>
+          <a:bodyPr wrap="none" rtlCol="0">
+            <a:spAutoFit/>
+          </a:bodyPr>
+          <a:lstStyle/>
+          <a:p>
+            <a:r>
+              <a:rPr lang="ar-AE" sz="2400" dirty="0"/>
+              <a:t>مَا اللَّهُ تَعَالَى مُتَمَكِّنًا بِمَكَانٍ</a:t>
+            </a:r>
+            <a:endParaRPr lang="tr-TR" sz="2400" dirty="0"/>
+          </a:p>
+        </p:txBody>
+      </p:sp>
+      <p:cxnSp>
+        <p:nvCxnSpPr>
+          <p:cNvPr id="12" name="Düz Ok Bağlayıcısı 11">
+            <a:extLst>
+              <a:ext uri="{FF2B5EF4-FFF2-40B4-BE49-F238E27FC236}">
+                <a16:creationId xmlns:a16="http://schemas.microsoft.com/office/drawing/2014/main" id="{81785152-9EBE-72CF-D577-3A3ACC237A90}"/>
+              </a:ext>
+            </a:extLst>
+          </p:cNvPr>
+          <p:cNvCxnSpPr>
+            <a:cxnSpLocks/>
+            <a:stCxn id="10" idx="3"/>
+            <a:endCxn id="13" idx="1"/>
+          </p:cNvCxnSpPr>
+          <p:nvPr/>
+        </p:nvCxnSpPr>
+        <p:spPr>
+          <a:xfrm flipV="1">
+            <a:off x="4473164" y="2763716"/>
+            <a:ext cx="1159540" cy="1"/>
+          </a:xfrm>
+          <a:prstGeom prst="straightConnector1">
+            <a:avLst/>
+          </a:prstGeom>
+          <a:ln>
+            <a:tailEnd type="triangle"/>
+          </a:ln>
+        </p:spPr>
+        <p:style>
+          <a:lnRef idx="2">
+            <a:schemeClr val="accent1"/>
+          </a:lnRef>
+          <a:fillRef idx="0">
+            <a:schemeClr val="accent1"/>
+          </a:fillRef>
+          <a:effectRef idx="1">
+            <a:schemeClr val="accent1"/>
+          </a:effectRef>
+          <a:fontRef idx="minor">
+            <a:schemeClr val="tx1"/>
+          </a:fontRef>
+        </p:style>
+      </p:cxnSp>
+      <p:sp>
+        <p:nvSpPr>
+          <p:cNvPr id="13" name="Metin kutusu 12">
+            <a:extLst>
+              <a:ext uri="{FF2B5EF4-FFF2-40B4-BE49-F238E27FC236}">
+                <a16:creationId xmlns:a16="http://schemas.microsoft.com/office/drawing/2014/main" id="{55F14169-6129-859B-49B6-4ABE30C6CE46}"/>
+              </a:ext>
+            </a:extLst>
+          </p:cNvPr>
+          <p:cNvSpPr txBox="1"/>
+          <p:nvPr/>
+        </p:nvSpPr>
+        <p:spPr>
+          <a:xfrm>
+            <a:off x="5632704" y="2579050"/>
+            <a:ext cx="4424866" cy="369332"/>
+          </a:xfrm>
+          <a:prstGeom prst="rect">
+            <a:avLst/>
+          </a:prstGeom>
+          <a:noFill/>
+        </p:spPr>
+        <p:txBody>
+          <a:bodyPr wrap="none" rtlCol="0">
+            <a:spAutoFit/>
+          </a:bodyPr>
+          <a:lstStyle/>
+          <a:p>
+            <a:r>
+              <a:rPr lang="tr-TR" dirty="0" err="1"/>
+              <a:t>Allah’u</a:t>
+            </a:r>
+            <a:r>
+              <a:rPr lang="tr-TR" dirty="0"/>
+              <a:t> Teala bir mekanda yerleşici değildir.</a:t>
+            </a:r>
+          </a:p>
+        </p:txBody>
+      </p:sp>
+      <p:sp>
+        <p:nvSpPr>
+          <p:cNvPr id="15" name="Metin kutusu 14">
+            <a:extLst>
+              <a:ext uri="{FF2B5EF4-FFF2-40B4-BE49-F238E27FC236}">
+                <a16:creationId xmlns:a16="http://schemas.microsoft.com/office/drawing/2014/main" id="{E17506B3-7547-CE0F-1AD6-A35840E0E915}"/>
+              </a:ext>
+            </a:extLst>
+          </p:cNvPr>
+          <p:cNvSpPr txBox="1"/>
+          <p:nvPr/>
+        </p:nvSpPr>
+        <p:spPr>
+          <a:xfrm>
+            <a:off x="606529" y="4094284"/>
+            <a:ext cx="2510046" cy="461665"/>
+          </a:xfrm>
+          <a:prstGeom prst="rect">
+            <a:avLst/>
+          </a:prstGeom>
+          <a:noFill/>
+        </p:spPr>
+        <p:txBody>
+          <a:bodyPr wrap="none" rtlCol="0">
+            <a:spAutoFit/>
+          </a:bodyPr>
+          <a:lstStyle/>
+          <a:p>
+            <a:r>
+              <a:rPr lang="ar-AE" sz="2400" b="1" dirty="0">
+                <a:solidFill>
+                  <a:srgbClr val="C00000"/>
+                </a:solidFill>
+              </a:rPr>
+              <a:t>لَا</a:t>
+            </a:r>
+            <a:r>
+              <a:rPr lang="tr-TR" sz="2400" b="1" dirty="0">
+                <a:solidFill>
+                  <a:srgbClr val="C00000"/>
+                </a:solidFill>
+              </a:rPr>
+              <a:t> Harfinin Misali:</a:t>
+            </a:r>
+          </a:p>
+        </p:txBody>
+      </p:sp>
+      <p:sp>
+        <p:nvSpPr>
+          <p:cNvPr id="18" name="Metin kutusu 17">
+            <a:extLst>
+              <a:ext uri="{FF2B5EF4-FFF2-40B4-BE49-F238E27FC236}">
+                <a16:creationId xmlns:a16="http://schemas.microsoft.com/office/drawing/2014/main" id="{BF6E1978-9673-F82D-28CA-B425B16A0F39}"/>
+              </a:ext>
+            </a:extLst>
+          </p:cNvPr>
+          <p:cNvSpPr txBox="1"/>
+          <p:nvPr/>
+        </p:nvSpPr>
+        <p:spPr>
+          <a:xfrm>
+            <a:off x="1934681" y="4566183"/>
+            <a:ext cx="2563522" cy="461665"/>
+          </a:xfrm>
+          <a:prstGeom prst="rect">
+            <a:avLst/>
+          </a:prstGeom>
+          <a:noFill/>
+        </p:spPr>
+        <p:txBody>
+          <a:bodyPr wrap="none" rtlCol="0">
+            <a:spAutoFit/>
+          </a:bodyPr>
+          <a:lstStyle/>
+          <a:p>
+            <a:r>
+              <a:rPr lang="ar-AE" sz="2400" dirty="0"/>
+              <a:t>لَا شَيْءٌ مُتَشَابِهًا لِلَّهِ تَعَالَى</a:t>
+            </a:r>
+            <a:endParaRPr lang="tr-TR" sz="2400" dirty="0"/>
+          </a:p>
+        </p:txBody>
+      </p:sp>
+      <p:sp>
+        <p:nvSpPr>
+          <p:cNvPr id="19" name="Metin kutusu 18">
+            <a:extLst>
+              <a:ext uri="{FF2B5EF4-FFF2-40B4-BE49-F238E27FC236}">
+                <a16:creationId xmlns:a16="http://schemas.microsoft.com/office/drawing/2014/main" id="{09F2D4EA-169A-4462-FF54-CE6DBE38A970}"/>
+              </a:ext>
+            </a:extLst>
+          </p:cNvPr>
+          <p:cNvSpPr txBox="1"/>
+          <p:nvPr/>
+        </p:nvSpPr>
+        <p:spPr>
+          <a:xfrm>
+            <a:off x="5705833" y="4612349"/>
+            <a:ext cx="4564135" cy="369332"/>
+          </a:xfrm>
+          <a:prstGeom prst="rect">
+            <a:avLst/>
+          </a:prstGeom>
+          <a:noFill/>
+        </p:spPr>
+        <p:txBody>
+          <a:bodyPr wrap="none" rtlCol="0">
+            <a:spAutoFit/>
+          </a:bodyPr>
+          <a:lstStyle/>
+          <a:p>
+            <a:r>
+              <a:rPr lang="tr-TR" dirty="0"/>
+              <a:t>Hiçbir şey </a:t>
+            </a:r>
+            <a:r>
+              <a:rPr lang="tr-TR" dirty="0" err="1"/>
+              <a:t>Allah’u</a:t>
+            </a:r>
+            <a:r>
+              <a:rPr lang="tr-TR" dirty="0"/>
+              <a:t> Teala’ya benzeyici değildir.</a:t>
+            </a:r>
+          </a:p>
+        </p:txBody>
+      </p:sp>
+      <p:cxnSp>
+        <p:nvCxnSpPr>
+          <p:cNvPr id="20" name="Düz Ok Bağlayıcısı 19">
+            <a:extLst>
+              <a:ext uri="{FF2B5EF4-FFF2-40B4-BE49-F238E27FC236}">
+                <a16:creationId xmlns:a16="http://schemas.microsoft.com/office/drawing/2014/main" id="{04EA0BFB-4C36-43E2-62D6-7A70782D8E8E}"/>
+              </a:ext>
+            </a:extLst>
+          </p:cNvPr>
+          <p:cNvCxnSpPr>
+            <a:cxnSpLocks/>
+            <a:stCxn id="18" idx="3"/>
+            <a:endCxn id="19" idx="1"/>
+          </p:cNvCxnSpPr>
+          <p:nvPr/>
+        </p:nvCxnSpPr>
+        <p:spPr>
+          <a:xfrm flipV="1">
+            <a:off x="4498203" y="4797015"/>
+            <a:ext cx="1207630" cy="1"/>
+          </a:xfrm>
+          <a:prstGeom prst="straightConnector1">
+            <a:avLst/>
+          </a:prstGeom>
+          <a:ln>
+            <a:tailEnd type="triangle"/>
+          </a:ln>
+        </p:spPr>
+        <p:style>
+          <a:lnRef idx="2">
+            <a:schemeClr val="accent1"/>
+          </a:lnRef>
+          <a:fillRef idx="0">
+            <a:schemeClr val="accent1"/>
+          </a:fillRef>
+          <a:effectRef idx="1">
+            <a:schemeClr val="accent1"/>
+          </a:effectRef>
+          <a:fontRef idx="minor">
+            <a:schemeClr val="tx1"/>
+          </a:fontRef>
+        </p:style>
+      </p:cxnSp>
     </p:spTree>
     <p:extLst>
       <p:ext uri="{BB962C8B-B14F-4D97-AF65-F5344CB8AC3E}">
         <p14:creationId xmlns:p14="http://schemas.microsoft.com/office/powerpoint/2010/main" val="3809376876"/>
+      </p:ext>
+    </p:extLst>
+  </p:cSld>
+  <p:clrMapOvr>
+    <a:masterClrMapping/>
+  </p:clrMapOvr>
+</p:sld>
+</file>
+
+<file path=ppt/slides/slide6.xml><?xml version="1.0" encoding="utf-8"?>
+<p:sld xmlns:a="http://schemas.openxmlformats.org/drawingml/2006/main" xmlns:r="http://schemas.openxmlformats.org/officeDocument/2006/relationships" xmlns:p="http://schemas.openxmlformats.org/presentationml/2006/main">
+  <p:cSld>
+    <p:spTree>
+      <p:nvGrpSpPr>
+        <p:cNvPr id="1" name=""/>
+        <p:cNvGrpSpPr/>
+        <p:nvPr/>
+      </p:nvGrpSpPr>
+      <p:grpSpPr>
+        <a:xfrm>
+          <a:off x="0" y="0"/>
+          <a:ext cx="0" cy="0"/>
+          <a:chOff x="0" y="0"/>
+          <a:chExt cx="0" cy="0"/>
+        </a:xfrm>
+      </p:grpSpPr>
+      <p:sp>
+        <p:nvSpPr>
+          <p:cNvPr id="2" name="Başlık 1">
+            <a:extLst>
+              <a:ext uri="{FF2B5EF4-FFF2-40B4-BE49-F238E27FC236}">
+                <a16:creationId xmlns:a16="http://schemas.microsoft.com/office/drawing/2014/main" id="{4F31AC6B-9B8F-F79D-2B52-3A31D83E3662}"/>
+              </a:ext>
+            </a:extLst>
+          </p:cNvPr>
+          <p:cNvSpPr>
+            <a:spLocks noGrp="1"/>
+          </p:cNvSpPr>
+          <p:nvPr>
+            <p:ph type="title"/>
+          </p:nvPr>
+        </p:nvSpPr>
+        <p:spPr>
+          <a:xfrm>
+            <a:off x="59267" y="30553"/>
+            <a:ext cx="12073465" cy="580525"/>
+          </a:xfrm>
+          <a:solidFill>
+            <a:srgbClr val="0070C0"/>
+          </a:solidFill>
+        </p:spPr>
+        <p:txBody>
+          <a:bodyPr>
+            <a:normAutofit fontScale="90000"/>
+          </a:bodyPr>
+          <a:lstStyle/>
+          <a:p>
+            <a:r>
+              <a:rPr lang="tr-TR" dirty="0">
+                <a:solidFill>
+                  <a:schemeClr val="bg1">
+                    <a:lumMod val="95000"/>
+                  </a:schemeClr>
+                </a:solidFill>
+                <a:latin typeface="Algerian" panose="04020705040A02060702" pitchFamily="82" charset="0"/>
+              </a:rPr>
+              <a:t>	AMİL-İ SEMAİ</a:t>
+            </a:r>
+          </a:p>
+        </p:txBody>
+      </p:sp>
+      <p:sp>
+        <p:nvSpPr>
+          <p:cNvPr id="3" name="Metin kutusu 2">
+            <a:extLst>
+              <a:ext uri="{FF2B5EF4-FFF2-40B4-BE49-F238E27FC236}">
+                <a16:creationId xmlns:a16="http://schemas.microsoft.com/office/drawing/2014/main" id="{46884D15-E418-F484-DBD1-B3020DA73FE4}"/>
+              </a:ext>
+            </a:extLst>
+          </p:cNvPr>
+          <p:cNvSpPr txBox="1"/>
+          <p:nvPr/>
+        </p:nvSpPr>
+        <p:spPr>
+          <a:xfrm>
+            <a:off x="8628017" y="120760"/>
+            <a:ext cx="3406702" cy="400110"/>
+          </a:xfrm>
+          <a:prstGeom prst="rect">
+            <a:avLst/>
+          </a:prstGeom>
+          <a:noFill/>
+        </p:spPr>
+        <p:txBody>
+          <a:bodyPr wrap="none" rtlCol="0">
+            <a:spAutoFit/>
+          </a:bodyPr>
+          <a:lstStyle/>
+          <a:p>
+            <a:r>
+              <a:rPr lang="tr-TR" sz="2000" i="1" u="sng" dirty="0" err="1">
+                <a:solidFill>
+                  <a:schemeClr val="bg1">
+                    <a:lumMod val="95000"/>
+                  </a:schemeClr>
+                </a:solidFill>
+                <a:latin typeface="Alef" panose="00000500000000000000" pitchFamily="2" charset="-79"/>
+                <a:cs typeface="Alef" panose="00000500000000000000" pitchFamily="2" charset="-79"/>
+              </a:rPr>
+              <a:t>Müzariyi</a:t>
+            </a:r>
+            <a:r>
+              <a:rPr lang="tr-TR" sz="2000" i="1" u="sng" dirty="0">
+                <a:solidFill>
+                  <a:schemeClr val="bg1">
+                    <a:lumMod val="95000"/>
+                  </a:schemeClr>
+                </a:solidFill>
+                <a:latin typeface="Alef" panose="00000500000000000000" pitchFamily="2" charset="-79"/>
+                <a:cs typeface="Alef" panose="00000500000000000000" pitchFamily="2" charset="-79"/>
+              </a:rPr>
+              <a:t> </a:t>
+            </a:r>
+            <a:r>
+              <a:rPr lang="tr-TR" sz="2000" i="1" u="sng" dirty="0" err="1">
+                <a:solidFill>
+                  <a:schemeClr val="bg1">
+                    <a:lumMod val="95000"/>
+                  </a:schemeClr>
+                </a:solidFill>
+                <a:latin typeface="Alef" panose="00000500000000000000" pitchFamily="2" charset="-79"/>
+                <a:cs typeface="Alef" panose="00000500000000000000" pitchFamily="2" charset="-79"/>
+              </a:rPr>
+              <a:t>Nasb</a:t>
+            </a:r>
+            <a:r>
+              <a:rPr lang="tr-TR" sz="2000" i="1" u="sng" dirty="0">
+                <a:solidFill>
+                  <a:schemeClr val="bg1">
+                    <a:lumMod val="95000"/>
+                  </a:schemeClr>
+                </a:solidFill>
+                <a:latin typeface="Alef" panose="00000500000000000000" pitchFamily="2" charset="-79"/>
+                <a:cs typeface="Alef" panose="00000500000000000000" pitchFamily="2" charset="-79"/>
+              </a:rPr>
+              <a:t> Eden Harfler</a:t>
+            </a:r>
+          </a:p>
+        </p:txBody>
+      </p:sp>
+      <p:graphicFrame>
+        <p:nvGraphicFramePr>
+          <p:cNvPr id="4" name="Tablo 3">
+            <a:extLst>
+              <a:ext uri="{FF2B5EF4-FFF2-40B4-BE49-F238E27FC236}">
+                <a16:creationId xmlns:a16="http://schemas.microsoft.com/office/drawing/2014/main" id="{68584F34-5760-A8FF-F508-8893A0F5A381}"/>
+              </a:ext>
+            </a:extLst>
+          </p:cNvPr>
+          <p:cNvGraphicFramePr>
+            <a:graphicFrameLocks noGrp="1"/>
+          </p:cNvGraphicFramePr>
+          <p:nvPr>
+            <p:extLst>
+              <p:ext uri="{D42A27DB-BD31-4B8C-83A1-F6EECF244321}">
+                <p14:modId xmlns:p14="http://schemas.microsoft.com/office/powerpoint/2010/main" val="2243975665"/>
+              </p:ext>
+            </p:extLst>
+          </p:nvPr>
+        </p:nvGraphicFramePr>
+        <p:xfrm>
+          <a:off x="59267" y="667258"/>
+          <a:ext cx="12073464" cy="3012627"/>
+        </p:xfrm>
+        <a:graphic>
+          <a:graphicData uri="http://schemas.openxmlformats.org/drawingml/2006/table">
+            <a:tbl>
+              <a:tblPr firstRow="1" bandRow="1">
+                <a:tableStyleId>{5C22544A-7EE6-4342-B048-85BDC9FD1C3A}</a:tableStyleId>
+              </a:tblPr>
+              <a:tblGrid>
+                <a:gridCol w="1247019">
+                  <a:extLst>
+                    <a:ext uri="{9D8B030D-6E8A-4147-A177-3AD203B41FA5}">
+                      <a16:colId xmlns:a16="http://schemas.microsoft.com/office/drawing/2014/main" val="3242288309"/>
+                    </a:ext>
+                  </a:extLst>
+                </a:gridCol>
+                <a:gridCol w="1750423">
+                  <a:extLst>
+                    <a:ext uri="{9D8B030D-6E8A-4147-A177-3AD203B41FA5}">
+                      <a16:colId xmlns:a16="http://schemas.microsoft.com/office/drawing/2014/main" val="2112445330"/>
+                    </a:ext>
+                  </a:extLst>
+                </a:gridCol>
+                <a:gridCol w="9076022">
+                  <a:extLst>
+                    <a:ext uri="{9D8B030D-6E8A-4147-A177-3AD203B41FA5}">
+                      <a16:colId xmlns:a16="http://schemas.microsoft.com/office/drawing/2014/main" val="317297140"/>
+                    </a:ext>
+                  </a:extLst>
+                </a:gridCol>
+              </a:tblGrid>
+              <a:tr h="629067">
+                <a:tc>
+                  <a:txBody>
+                    <a:bodyPr/>
+                    <a:lstStyle/>
+                    <a:p>
+                      <a:r>
+                        <a:rPr lang="tr-TR" dirty="0"/>
+                        <a:t>Harf-i Cer</a:t>
+                      </a:r>
+                    </a:p>
+                  </a:txBody>
+                  <a:tcPr/>
+                </a:tc>
+                <a:tc>
+                  <a:txBody>
+                    <a:bodyPr/>
+                    <a:lstStyle/>
+                    <a:p>
+                      <a:r>
+                        <a:rPr lang="tr-TR" dirty="0"/>
+                        <a:t>Mana</a:t>
+                      </a:r>
+                    </a:p>
+                  </a:txBody>
+                  <a:tcPr/>
+                </a:tc>
+                <a:tc>
+                  <a:txBody>
+                    <a:bodyPr/>
+                    <a:lstStyle/>
+                    <a:p>
+                      <a:r>
+                        <a:rPr lang="tr-TR" dirty="0"/>
+                        <a:t>Misal</a:t>
+                      </a:r>
+                    </a:p>
+                  </a:txBody>
+                  <a:tcPr/>
+                </a:tc>
+                <a:extLst>
+                  <a:ext uri="{0D108BD9-81ED-4DB2-BD59-A6C34878D82A}">
+                    <a16:rowId xmlns:a16="http://schemas.microsoft.com/office/drawing/2014/main" val="3289731430"/>
+                  </a:ext>
+                </a:extLst>
+              </a:tr>
+              <a:tr h="449333">
+                <a:tc>
+                  <a:txBody>
+                    <a:bodyPr/>
+                    <a:lstStyle/>
+                    <a:p>
+                      <a:pPr algn="ctr"/>
+                      <a:r>
+                        <a:rPr lang="ar-AE" sz="2400" b="1" dirty="0">
+                          <a:solidFill>
+                            <a:srgbClr val="C00000"/>
+                          </a:solidFill>
+                          <a:latin typeface="Algerian" panose="04020705040A02060702" pitchFamily="82" charset="0"/>
+                        </a:rPr>
+                        <a:t>أَنْ</a:t>
+                      </a:r>
+                      <a:endParaRPr lang="tr-TR" sz="2400" b="1" dirty="0">
+                        <a:solidFill>
+                          <a:srgbClr val="C00000"/>
+                        </a:solidFill>
+                        <a:latin typeface="Algerian" panose="04020705040A02060702" pitchFamily="82" charset="0"/>
+                      </a:endParaRPr>
+                    </a:p>
+                  </a:txBody>
+                  <a:tcPr/>
+                </a:tc>
+                <a:tc>
+                  <a:txBody>
+                    <a:bodyPr/>
+                    <a:lstStyle/>
+                    <a:p>
+                      <a:pPr algn="ctr"/>
+                      <a:r>
+                        <a:rPr lang="tr-TR" sz="1800" dirty="0"/>
+                        <a:t>…</a:t>
+                      </a:r>
+                      <a:r>
+                        <a:rPr lang="tr-TR" sz="1800" dirty="0" err="1"/>
+                        <a:t>mek</a:t>
+                      </a:r>
+                      <a:r>
+                        <a:rPr lang="tr-TR" sz="1800" dirty="0"/>
+                        <a:t>/…</a:t>
+                      </a:r>
+                      <a:r>
+                        <a:rPr lang="tr-TR" sz="1800" dirty="0" err="1"/>
+                        <a:t>mak</a:t>
+                      </a:r>
+                      <a:endParaRPr lang="tr-TR" sz="1800" dirty="0"/>
+                    </a:p>
+                  </a:txBody>
+                  <a:tcPr/>
+                </a:tc>
+                <a:tc>
+                  <a:txBody>
+                    <a:bodyPr/>
+                    <a:lstStyle/>
+                    <a:p>
+                      <a:pPr algn="ctr"/>
+                      <a:r>
+                        <a:rPr lang="tr-TR" sz="1600" b="1" kern="1200" dirty="0">
+                          <a:solidFill>
+                            <a:schemeClr val="tx1"/>
+                          </a:solidFill>
+                          <a:latin typeface="Arabic Typesetting" panose="03020402040406030203" pitchFamily="66" charset="-78"/>
+                          <a:ea typeface="Amiri" panose="00000500000000000000" pitchFamily="2" charset="-78"/>
+                          <a:cs typeface="Arabic Typesetting" panose="03020402040406030203" pitchFamily="66" charset="-78"/>
+                        </a:rPr>
+                        <a:t> </a:t>
+                      </a:r>
+                      <a:r>
+                        <a:rPr lang="ar-AE" sz="1600" b="1" kern="1200" dirty="0">
+                          <a:solidFill>
+                            <a:srgbClr val="C00000"/>
+                          </a:solidFill>
+                          <a:latin typeface="Arabic Typesetting" panose="03020402040406030203" pitchFamily="66" charset="-78"/>
+                          <a:ea typeface="Amiri" panose="00000500000000000000" pitchFamily="2" charset="-78"/>
+                          <a:cs typeface="Arabic Typesetting" panose="03020402040406030203" pitchFamily="66" charset="-78"/>
+                        </a:rPr>
+                        <a:t>أَنْ </a:t>
+                      </a:r>
+                      <a:r>
+                        <a:rPr lang="ar-AE" sz="1600" b="1" kern="1200" dirty="0">
+                          <a:solidFill>
+                            <a:schemeClr val="tx1"/>
+                          </a:solidFill>
+                          <a:latin typeface="Arabic Typesetting" panose="03020402040406030203" pitchFamily="66" charset="-78"/>
+                          <a:ea typeface="Amiri" panose="00000500000000000000" pitchFamily="2" charset="-78"/>
+                          <a:cs typeface="Arabic Typesetting" panose="03020402040406030203" pitchFamily="66" charset="-78"/>
+                        </a:rPr>
+                        <a:t>أُحِبُّ أُطِيعَ اللَّهَ</a:t>
+                      </a:r>
+                      <a:r>
+                        <a:rPr lang="tr-TR" sz="1600" b="1" kern="1200" dirty="0">
+                          <a:solidFill>
+                            <a:schemeClr val="tx1"/>
+                          </a:solidFill>
+                          <a:latin typeface="Arabic Typesetting" panose="03020402040406030203" pitchFamily="66" charset="-78"/>
+                          <a:ea typeface="Amiri" panose="00000500000000000000" pitchFamily="2" charset="-78"/>
+                          <a:cs typeface="Arabic Typesetting" panose="03020402040406030203" pitchFamily="66" charset="-78"/>
+                        </a:rPr>
+                        <a:t> /</a:t>
+                      </a:r>
+                      <a:r>
+                        <a:rPr lang="tr-TR" sz="1600" b="1" kern="1200" dirty="0">
+                          <a:solidFill>
+                            <a:schemeClr val="accent6">
+                              <a:lumMod val="50000"/>
+                            </a:schemeClr>
+                          </a:solidFill>
+                          <a:latin typeface="Arabic Typesetting" panose="03020402040406030203" pitchFamily="66" charset="-78"/>
+                          <a:ea typeface="Amiri" panose="00000500000000000000" pitchFamily="2" charset="-78"/>
+                          <a:cs typeface="Arabic Typesetting" panose="03020402040406030203" pitchFamily="66" charset="-78"/>
+                        </a:rPr>
+                        <a:t>  </a:t>
+                      </a:r>
+                      <a:r>
+                        <a:rPr lang="tr-TR" sz="1600" b="1" kern="1200" dirty="0">
+                          <a:solidFill>
+                            <a:schemeClr val="tx1"/>
+                          </a:solidFill>
+                          <a:latin typeface="Arabic Typesetting" panose="03020402040406030203" pitchFamily="66" charset="-78"/>
+                          <a:ea typeface="Amiri" panose="00000500000000000000" pitchFamily="2" charset="-78"/>
+                          <a:cs typeface="Arabic Typesetting" panose="03020402040406030203" pitchFamily="66" charset="-78"/>
+                        </a:rPr>
+                        <a:t>Allah’a itaat etmeyi seviyorum.</a:t>
+                      </a:r>
+                      <a:endParaRPr lang="tr-TR" sz="1600" b="1" kern="1200" dirty="0">
+                        <a:solidFill>
+                          <a:schemeClr val="accent6">
+                            <a:lumMod val="50000"/>
+                          </a:schemeClr>
+                        </a:solidFill>
+                        <a:latin typeface="Arabic Typesetting" panose="03020402040406030203" pitchFamily="66" charset="-78"/>
+                        <a:ea typeface="Amiri" panose="00000500000000000000" pitchFamily="2" charset="-78"/>
+                        <a:cs typeface="Arabic Typesetting" panose="03020402040406030203" pitchFamily="66" charset="-78"/>
+                      </a:endParaRPr>
+                    </a:p>
+                  </a:txBody>
+                  <a:tcPr/>
+                </a:tc>
+                <a:extLst>
+                  <a:ext uri="{0D108BD9-81ED-4DB2-BD59-A6C34878D82A}">
+                    <a16:rowId xmlns:a16="http://schemas.microsoft.com/office/drawing/2014/main" val="3898272618"/>
+                  </a:ext>
+                </a:extLst>
+              </a:tr>
+              <a:tr h="449333">
+                <a:tc>
+                  <a:txBody>
+                    <a:bodyPr/>
+                    <a:lstStyle/>
+                    <a:p>
+                      <a:pPr algn="ctr"/>
+                      <a:r>
+                        <a:rPr lang="ar-AE" sz="2400" b="1" dirty="0">
+                          <a:solidFill>
+                            <a:srgbClr val="C00000"/>
+                          </a:solidFill>
+                          <a:latin typeface="Algerian" panose="04020705040A02060702" pitchFamily="82" charset="0"/>
+                        </a:rPr>
+                        <a:t>لَنْ</a:t>
+                      </a:r>
+                      <a:endParaRPr lang="tr-TR" sz="2400" b="1" dirty="0">
+                        <a:solidFill>
+                          <a:srgbClr val="C00000"/>
+                        </a:solidFill>
+                        <a:latin typeface="Algerian" panose="04020705040A02060702" pitchFamily="82" charset="0"/>
+                      </a:endParaRPr>
+                    </a:p>
+                  </a:txBody>
+                  <a:tcPr/>
+                </a:tc>
+                <a:tc>
+                  <a:txBody>
+                    <a:bodyPr/>
+                    <a:lstStyle/>
+                    <a:p>
+                      <a:pPr algn="ctr"/>
+                      <a:r>
+                        <a:rPr lang="tr-TR" sz="1800" dirty="0"/>
+                        <a:t>…</a:t>
+                      </a:r>
+                      <a:r>
+                        <a:rPr lang="tr-TR" sz="1800" dirty="0" err="1"/>
+                        <a:t>ecek</a:t>
+                      </a:r>
+                      <a:r>
+                        <a:rPr lang="tr-TR" sz="1800" dirty="0"/>
+                        <a:t>/…</a:t>
+                      </a:r>
+                      <a:r>
+                        <a:rPr lang="tr-TR" sz="1800" dirty="0" err="1"/>
+                        <a:t>acak</a:t>
+                      </a:r>
+                      <a:r>
+                        <a:rPr lang="tr-TR" sz="1800" dirty="0"/>
+                        <a:t> Asla</a:t>
+                      </a:r>
+                    </a:p>
+                  </a:txBody>
+                  <a:tcPr/>
+                </a:tc>
+                <a:tc>
+                  <a:txBody>
+                    <a:bodyPr/>
+                    <a:lstStyle/>
+                    <a:p>
+                      <a:pPr algn="ctr"/>
+                      <a:r>
+                        <a:rPr lang="tr-TR" sz="1600" b="1" kern="1200" dirty="0">
+                          <a:solidFill>
+                            <a:srgbClr val="C00000"/>
+                          </a:solidFill>
+                          <a:latin typeface="Arabic Typesetting" panose="03020402040406030203" pitchFamily="66" charset="-78"/>
+                          <a:ea typeface="Amiri" panose="00000500000000000000" pitchFamily="2" charset="-78"/>
+                          <a:cs typeface="Arabic Typesetting" panose="03020402040406030203" pitchFamily="66" charset="-78"/>
+                        </a:rPr>
+                        <a:t> </a:t>
+                      </a:r>
+                      <a:r>
+                        <a:rPr lang="ar-AE" sz="1600" b="1" kern="1200" dirty="0">
+                          <a:solidFill>
+                            <a:srgbClr val="C00000"/>
+                          </a:solidFill>
+                          <a:latin typeface="Arabic Typesetting" panose="03020402040406030203" pitchFamily="66" charset="-78"/>
+                          <a:ea typeface="Amiri" panose="00000500000000000000" pitchFamily="2" charset="-78"/>
+                          <a:cs typeface="Arabic Typesetting" panose="03020402040406030203" pitchFamily="66" charset="-78"/>
+                        </a:rPr>
+                        <a:t>لَنْ</a:t>
+                      </a:r>
+                      <a:r>
+                        <a:rPr lang="ar-AE" sz="1600" b="1" kern="1200" dirty="0">
+                          <a:solidFill>
+                            <a:schemeClr val="tx1"/>
+                          </a:solidFill>
+                          <a:latin typeface="Arabic Typesetting" panose="03020402040406030203" pitchFamily="66" charset="-78"/>
+                          <a:ea typeface="Amiri" panose="00000500000000000000" pitchFamily="2" charset="-78"/>
+                          <a:cs typeface="Arabic Typesetting" panose="03020402040406030203" pitchFamily="66" charset="-78"/>
+                        </a:rPr>
+                        <a:t> يَغْفِرَ اللَّهُ تَعَالَى لِلْكَافِرِينَ</a:t>
+                      </a:r>
+                      <a:r>
+                        <a:rPr lang="tr-TR" sz="1600" b="1" kern="1200" dirty="0">
+                          <a:solidFill>
+                            <a:schemeClr val="tx1"/>
+                          </a:solidFill>
+                          <a:latin typeface="Arabic Typesetting" panose="03020402040406030203" pitchFamily="66" charset="-78"/>
+                          <a:ea typeface="Amiri" panose="00000500000000000000" pitchFamily="2" charset="-78"/>
+                          <a:cs typeface="Arabic Typesetting" panose="03020402040406030203" pitchFamily="66" charset="-78"/>
+                        </a:rPr>
+                        <a:t> </a:t>
+                      </a:r>
+                      <a:r>
+                        <a:rPr lang="tr-TR" sz="1600" b="1" dirty="0">
+                          <a:solidFill>
+                            <a:schemeClr val="tx1"/>
+                          </a:solidFill>
+                          <a:latin typeface="Arabic Typesetting" panose="03020402040406030203" pitchFamily="66" charset="-78"/>
+                          <a:cs typeface="Arabic Typesetting" panose="03020402040406030203" pitchFamily="66" charset="-78"/>
+                        </a:rPr>
+                        <a:t>/ Elbette Allah Teala kafirleri mağfiret etmeyecek.</a:t>
+                      </a:r>
+                    </a:p>
+                  </a:txBody>
+                  <a:tcPr/>
+                </a:tc>
+                <a:extLst>
+                  <a:ext uri="{0D108BD9-81ED-4DB2-BD59-A6C34878D82A}">
+                    <a16:rowId xmlns:a16="http://schemas.microsoft.com/office/drawing/2014/main" val="2209876613"/>
+                  </a:ext>
+                </a:extLst>
+              </a:tr>
+              <a:tr h="463320">
+                <a:tc>
+                  <a:txBody>
+                    <a:bodyPr/>
+                    <a:lstStyle/>
+                    <a:p>
+                      <a:pPr algn="ctr"/>
+                      <a:r>
+                        <a:rPr lang="ar-AE" sz="2400" b="1" dirty="0">
+                          <a:solidFill>
+                            <a:srgbClr val="C00000"/>
+                          </a:solidFill>
+                          <a:latin typeface="Algerian" panose="04020705040A02060702" pitchFamily="82" charset="0"/>
+                        </a:rPr>
+                        <a:t>كَىْ</a:t>
+                      </a:r>
+                      <a:endParaRPr lang="tr-TR" sz="2400" b="1" dirty="0">
+                        <a:solidFill>
+                          <a:srgbClr val="C00000"/>
+                        </a:solidFill>
+                        <a:latin typeface="Algerian" panose="04020705040A02060702" pitchFamily="82" charset="0"/>
+                      </a:endParaRPr>
+                    </a:p>
+                  </a:txBody>
+                  <a:tcPr/>
+                </a:tc>
+                <a:tc>
+                  <a:txBody>
+                    <a:bodyPr/>
+                    <a:lstStyle/>
+                    <a:p>
+                      <a:pPr algn="ctr"/>
+                      <a:r>
+                        <a:rPr lang="tr-TR" sz="1800" dirty="0"/>
+                        <a:t>İçin </a:t>
+                      </a:r>
+                    </a:p>
+                  </a:txBody>
+                  <a:tcPr/>
+                </a:tc>
+                <a:tc>
+                  <a:txBody>
+                    <a:bodyPr/>
+                    <a:lstStyle/>
+                    <a:p>
+                      <a:pPr algn="ctr"/>
+                      <a:r>
+                        <a:rPr lang="ar-AE" sz="1600" b="1" dirty="0">
+                          <a:solidFill>
+                            <a:schemeClr val="tx1"/>
+                          </a:solidFill>
+                          <a:latin typeface="Arabic Typesetting" panose="03020402040406030203" pitchFamily="66" charset="-78"/>
+                          <a:cs typeface="Arabic Typesetting" panose="03020402040406030203" pitchFamily="66" charset="-78"/>
+                        </a:rPr>
+                        <a:t>أُحِبُّ</a:t>
+                      </a:r>
+                      <a:r>
+                        <a:rPr lang="ar-AE" sz="1600" b="1" dirty="0">
+                          <a:solidFill>
+                            <a:srgbClr val="C00000"/>
+                          </a:solidFill>
+                          <a:latin typeface="Arabic Typesetting" panose="03020402040406030203" pitchFamily="66" charset="-78"/>
+                          <a:cs typeface="Arabic Typesetting" panose="03020402040406030203" pitchFamily="66" charset="-78"/>
+                        </a:rPr>
+                        <a:t> </a:t>
+                      </a:r>
+                      <a:r>
+                        <a:rPr lang="ar-AE" sz="1600" b="1" dirty="0">
+                          <a:solidFill>
+                            <a:schemeClr val="tx1"/>
+                          </a:solidFill>
+                          <a:latin typeface="Arabic Typesetting" panose="03020402040406030203" pitchFamily="66" charset="-78"/>
+                          <a:cs typeface="Arabic Typesetting" panose="03020402040406030203" pitchFamily="66" charset="-78"/>
+                        </a:rPr>
+                        <a:t>طُولَ الْعُمْرِ </a:t>
+                      </a:r>
+                      <a:r>
+                        <a:rPr lang="ar-AE" sz="1600" b="1" dirty="0">
+                          <a:solidFill>
+                            <a:srgbClr val="C00000"/>
+                          </a:solidFill>
+                          <a:latin typeface="Arabic Typesetting" panose="03020402040406030203" pitchFamily="66" charset="-78"/>
+                          <a:cs typeface="Arabic Typesetting" panose="03020402040406030203" pitchFamily="66" charset="-78"/>
+                        </a:rPr>
+                        <a:t>كَىْ</a:t>
+                      </a:r>
+                      <a:r>
+                        <a:rPr lang="ar-AE" sz="1600" b="1" dirty="0">
+                          <a:solidFill>
+                            <a:schemeClr val="tx1"/>
+                          </a:solidFill>
+                          <a:latin typeface="Arabic Typesetting" panose="03020402040406030203" pitchFamily="66" charset="-78"/>
+                          <a:cs typeface="Arabic Typesetting" panose="03020402040406030203" pitchFamily="66" charset="-78"/>
+                        </a:rPr>
+                        <a:t> أُحَصِّلَ الْعِلْمَ</a:t>
+                      </a:r>
+                      <a:r>
+                        <a:rPr lang="tr-TR" sz="1600" b="1" dirty="0">
+                          <a:solidFill>
+                            <a:srgbClr val="C00000"/>
+                          </a:solidFill>
+                          <a:latin typeface="Arabic Typesetting" panose="03020402040406030203" pitchFamily="66" charset="-78"/>
+                          <a:cs typeface="Arabic Typesetting" panose="03020402040406030203" pitchFamily="66" charset="-78"/>
+                        </a:rPr>
+                        <a:t> </a:t>
+                      </a:r>
+                      <a:r>
+                        <a:rPr lang="tr-TR" sz="1600" b="1" dirty="0">
+                          <a:solidFill>
+                            <a:schemeClr val="tx1"/>
+                          </a:solidFill>
+                          <a:latin typeface="Arabic Typesetting" panose="03020402040406030203" pitchFamily="66" charset="-78"/>
+                          <a:cs typeface="Arabic Typesetting" panose="03020402040406030203" pitchFamily="66" charset="-78"/>
+                        </a:rPr>
+                        <a:t>/</a:t>
+                      </a:r>
+                      <a:r>
+                        <a:rPr lang="tr-TR" sz="1600" b="1" dirty="0">
+                          <a:solidFill>
+                            <a:schemeClr val="accent6">
+                              <a:lumMod val="50000"/>
+                            </a:schemeClr>
+                          </a:solidFill>
+                          <a:latin typeface="Arabic Typesetting" panose="03020402040406030203" pitchFamily="66" charset="-78"/>
+                          <a:cs typeface="Arabic Typesetting" panose="03020402040406030203" pitchFamily="66" charset="-78"/>
+                        </a:rPr>
+                        <a:t>  </a:t>
+                      </a:r>
+                      <a:r>
+                        <a:rPr lang="tr-TR" sz="1600" b="1" dirty="0">
+                          <a:solidFill>
+                            <a:schemeClr val="tx1"/>
+                          </a:solidFill>
+                          <a:latin typeface="Arabic Typesetting" panose="03020402040406030203" pitchFamily="66" charset="-78"/>
+                          <a:cs typeface="Arabic Typesetting" panose="03020402040406030203" pitchFamily="66" charset="-78"/>
+                        </a:rPr>
+                        <a:t>İlim tahsil etmek için ömrün uzun olmasını seviyorum.</a:t>
+                      </a:r>
+                    </a:p>
+                  </a:txBody>
+                  <a:tcPr/>
+                </a:tc>
+                <a:extLst>
+                  <a:ext uri="{0D108BD9-81ED-4DB2-BD59-A6C34878D82A}">
+                    <a16:rowId xmlns:a16="http://schemas.microsoft.com/office/drawing/2014/main" val="1718483269"/>
+                  </a:ext>
+                </a:extLst>
+              </a:tr>
+              <a:tr h="463320">
+                <a:tc>
+                  <a:txBody>
+                    <a:bodyPr/>
+                    <a:lstStyle/>
+                    <a:p>
+                      <a:pPr algn="ctr"/>
+                      <a:r>
+                        <a:rPr lang="ar-AE" sz="2400" b="1" dirty="0">
+                          <a:solidFill>
+                            <a:srgbClr val="C00000"/>
+                          </a:solidFill>
+                          <a:latin typeface="Algerian" panose="04020705040A02060702" pitchFamily="82" charset="0"/>
+                        </a:rPr>
+                        <a:t>إِذَنْ</a:t>
+                      </a:r>
+                      <a:endParaRPr lang="tr-TR" sz="2400" b="1" dirty="0">
+                        <a:solidFill>
+                          <a:srgbClr val="C00000"/>
+                        </a:solidFill>
+                        <a:latin typeface="Algerian" panose="04020705040A02060702" pitchFamily="82" charset="0"/>
+                      </a:endParaRPr>
+                    </a:p>
+                  </a:txBody>
+                  <a:tcPr/>
+                </a:tc>
+                <a:tc>
+                  <a:txBody>
+                    <a:bodyPr/>
+                    <a:lstStyle/>
+                    <a:p>
+                      <a:pPr algn="ctr"/>
+                      <a:r>
+                        <a:rPr lang="tr-TR" sz="1800" dirty="0"/>
+                        <a:t>Öyleyse</a:t>
+                      </a:r>
+                    </a:p>
+                  </a:txBody>
+                  <a:tcPr/>
+                </a:tc>
+                <a:tc>
+                  <a:txBody>
+                    <a:bodyPr/>
+                    <a:lstStyle/>
+                    <a:p>
+                      <a:pPr algn="ctr"/>
+                      <a:r>
+                        <a:rPr lang="tr-TR" sz="1600" b="1" dirty="0">
+                          <a:solidFill>
+                            <a:schemeClr val="tx1"/>
+                          </a:solidFill>
+                          <a:latin typeface="Arabic Typesetting" panose="03020402040406030203" pitchFamily="66" charset="-78"/>
+                          <a:cs typeface="Arabic Typesetting" panose="03020402040406030203" pitchFamily="66" charset="-78"/>
+                        </a:rPr>
+                        <a:t>Ben </a:t>
+                      </a:r>
+                      <a:r>
+                        <a:rPr lang="tr-TR" sz="1600" b="1" dirty="0" err="1">
+                          <a:solidFill>
+                            <a:schemeClr val="tx1"/>
+                          </a:solidFill>
+                          <a:latin typeface="Arabic Typesetting" panose="03020402040406030203" pitchFamily="66" charset="-78"/>
+                          <a:cs typeface="Arabic Typesetting" panose="03020402040406030203" pitchFamily="66" charset="-78"/>
+                        </a:rPr>
+                        <a:t>Allah’u</a:t>
+                      </a:r>
+                      <a:r>
+                        <a:rPr lang="tr-TR" sz="1600" b="1" dirty="0">
+                          <a:solidFill>
+                            <a:schemeClr val="tx1"/>
+                          </a:solidFill>
+                          <a:latin typeface="Arabic Typesetting" panose="03020402040406030203" pitchFamily="66" charset="-78"/>
+                          <a:cs typeface="Arabic Typesetting" panose="03020402040406030203" pitchFamily="66" charset="-78"/>
+                        </a:rPr>
+                        <a:t> Teala’ya itaat ediyorum</a:t>
+                      </a:r>
+                      <a:r>
+                        <a:rPr lang="tr-TR" sz="1200" b="0" dirty="0">
+                          <a:solidFill>
+                            <a:schemeClr val="tx1"/>
+                          </a:solidFill>
+                          <a:latin typeface="Arabic Typesetting" panose="03020402040406030203" pitchFamily="66" charset="-78"/>
+                          <a:cs typeface="Arabic Typesetting" panose="03020402040406030203" pitchFamily="66" charset="-78"/>
+                        </a:rPr>
+                        <a:t>. </a:t>
+                      </a:r>
+                      <a:r>
+                        <a:rPr lang="tr-TR" sz="1400" b="0" dirty="0">
+                          <a:solidFill>
+                            <a:schemeClr val="tx1"/>
+                          </a:solidFill>
+                          <a:latin typeface="Arabic Typesetting" panose="03020402040406030203" pitchFamily="66" charset="-78"/>
+                          <a:cs typeface="Arabic Typesetting" panose="03020402040406030203" pitchFamily="66" charset="-78"/>
+                        </a:rPr>
+                        <a:t>(Diyen birine)</a:t>
+                      </a:r>
+                      <a:endParaRPr lang="tr-TR" sz="1800" b="0" dirty="0">
+                        <a:solidFill>
+                          <a:schemeClr val="tx1"/>
+                        </a:solidFill>
+                        <a:latin typeface="Arabic Typesetting" panose="03020402040406030203" pitchFamily="66" charset="-78"/>
+                        <a:cs typeface="Arabic Typesetting" panose="03020402040406030203" pitchFamily="66" charset="-78"/>
+                      </a:endParaRPr>
+                    </a:p>
+                    <a:p>
+                      <a:pPr algn="ctr"/>
+                      <a:endParaRPr lang="tr-TR" sz="1600" b="1" dirty="0">
+                        <a:solidFill>
+                          <a:schemeClr val="tx1"/>
+                        </a:solidFill>
+                        <a:latin typeface="Arabic Typesetting" panose="03020402040406030203" pitchFamily="66" charset="-78"/>
+                        <a:cs typeface="Arabic Typesetting" panose="03020402040406030203" pitchFamily="66" charset="-78"/>
+                      </a:endParaRPr>
+                    </a:p>
+                    <a:p>
+                      <a:pPr marL="0" marR="0" lvl="0" indent="0" algn="ctr" defTabSz="914400" rtl="0" eaLnBrk="1" fontAlgn="auto" latinLnBrk="0" hangingPunct="1">
+                        <a:lnSpc>
+                          <a:spcPct val="100000"/>
+                        </a:lnSpc>
+                        <a:spcBef>
+                          <a:spcPts val="0"/>
+                        </a:spcBef>
+                        <a:spcAft>
+                          <a:spcPts val="0"/>
+                        </a:spcAft>
+                        <a:buClrTx/>
+                        <a:buSzTx/>
+                        <a:buFontTx/>
+                        <a:buNone/>
+                        <a:tabLst/>
+                        <a:defRPr/>
+                      </a:pPr>
+                      <a:r>
+                        <a:rPr lang="ar-AE" sz="1600" b="1" dirty="0">
+                          <a:solidFill>
+                            <a:srgbClr val="C00000"/>
+                          </a:solidFill>
+                          <a:latin typeface="Arabic Typesetting" panose="03020402040406030203" pitchFamily="66" charset="-78"/>
+                          <a:cs typeface="Arabic Typesetting" panose="03020402040406030203" pitchFamily="66" charset="-78"/>
+                        </a:rPr>
+                        <a:t>إِذَنْ </a:t>
+                      </a:r>
+                      <a:r>
+                        <a:rPr lang="ar-AE" sz="1600" b="1" dirty="0">
+                          <a:solidFill>
+                            <a:schemeClr val="tx1"/>
+                          </a:solidFill>
+                          <a:latin typeface="Arabic Typesetting" panose="03020402040406030203" pitchFamily="66" charset="-78"/>
+                          <a:cs typeface="Arabic Typesetting" panose="03020402040406030203" pitchFamily="66" charset="-78"/>
+                        </a:rPr>
+                        <a:t>تَدْخُلَ الْجَنَّةَ</a:t>
+                      </a:r>
+                      <a:r>
+                        <a:rPr lang="tr-TR" sz="1600" b="1" dirty="0">
+                          <a:solidFill>
+                            <a:schemeClr val="tx1"/>
+                          </a:solidFill>
+                          <a:latin typeface="Arabic Typesetting" panose="03020402040406030203" pitchFamily="66" charset="-78"/>
+                          <a:cs typeface="Arabic Typesetting" panose="03020402040406030203" pitchFamily="66" charset="-78"/>
+                        </a:rPr>
+                        <a:t> / Öyleyse cennete girersin. </a:t>
+                      </a:r>
+                      <a:r>
+                        <a:rPr lang="tr-TR" sz="1400" b="0" dirty="0">
+                          <a:solidFill>
+                            <a:schemeClr val="tx1"/>
+                          </a:solidFill>
+                          <a:latin typeface="Arabic Typesetting" panose="03020402040406030203" pitchFamily="66" charset="-78"/>
+                          <a:cs typeface="Arabic Typesetting" panose="03020402040406030203" pitchFamily="66" charset="-78"/>
+                        </a:rPr>
+                        <a:t>(Verilen cevap)</a:t>
+                      </a:r>
+                      <a:endParaRPr lang="tr-TR" sz="1600" b="0" dirty="0">
+                        <a:solidFill>
+                          <a:schemeClr val="tx1"/>
+                        </a:solidFill>
+                        <a:latin typeface="Arabic Typesetting" panose="03020402040406030203" pitchFamily="66" charset="-78"/>
+                        <a:cs typeface="Arabic Typesetting" panose="03020402040406030203" pitchFamily="66" charset="-78"/>
+                      </a:endParaRPr>
+                    </a:p>
+                  </a:txBody>
+                  <a:tcPr/>
+                </a:tc>
+                <a:extLst>
+                  <a:ext uri="{0D108BD9-81ED-4DB2-BD59-A6C34878D82A}">
+                    <a16:rowId xmlns:a16="http://schemas.microsoft.com/office/drawing/2014/main" val="98950525"/>
+                  </a:ext>
+                </a:extLst>
+              </a:tr>
+            </a:tbl>
+          </a:graphicData>
+        </a:graphic>
+      </p:graphicFrame>
+      <p:pic>
+        <p:nvPicPr>
+          <p:cNvPr id="9" name="Resim 8">
+            <a:extLst>
+              <a:ext uri="{FF2B5EF4-FFF2-40B4-BE49-F238E27FC236}">
+                <a16:creationId xmlns:a16="http://schemas.microsoft.com/office/drawing/2014/main" id="{A24E9D9E-9435-21E0-5D0D-72152AA417F0}"/>
+              </a:ext>
+            </a:extLst>
+          </p:cNvPr>
+          <p:cNvPicPr>
+            <a:picLocks noChangeAspect="1"/>
+          </p:cNvPicPr>
+          <p:nvPr/>
+        </p:nvPicPr>
+        <p:blipFill>
+          <a:blip r:embed="rId3">
+            <a:extLst>
+              <a:ext uri="{28A0092B-C50C-407E-A947-70E740481C1C}">
+                <a14:useLocalDpi xmlns:a14="http://schemas.microsoft.com/office/drawing/2010/main" val="0"/>
+              </a:ext>
+            </a:extLst>
+          </a:blip>
+          <a:stretch>
+            <a:fillRect/>
+          </a:stretch>
+        </p:blipFill>
+        <p:spPr>
+          <a:xfrm>
+            <a:off x="5968151" y="2909146"/>
+            <a:ext cx="184574" cy="184574"/>
+          </a:xfrm>
+          <a:prstGeom prst="rect">
+            <a:avLst/>
+          </a:prstGeom>
+        </p:spPr>
+      </p:pic>
+      <p:pic>
+        <p:nvPicPr>
+          <p:cNvPr id="14" name="Resim 13">
+            <a:extLst>
+              <a:ext uri="{FF2B5EF4-FFF2-40B4-BE49-F238E27FC236}">
+                <a16:creationId xmlns:a16="http://schemas.microsoft.com/office/drawing/2014/main" id="{CD6270F0-8F79-4FCC-2590-290A7CDFB589}"/>
+              </a:ext>
+            </a:extLst>
+          </p:cNvPr>
+          <p:cNvPicPr>
+            <a:picLocks noChangeAspect="1"/>
+          </p:cNvPicPr>
+          <p:nvPr/>
+        </p:nvPicPr>
+        <p:blipFill>
+          <a:blip r:embed="rId4">
+            <a:extLst>
+              <a:ext uri="{28A0092B-C50C-407E-A947-70E740481C1C}">
+                <a14:useLocalDpi xmlns:a14="http://schemas.microsoft.com/office/drawing/2010/main" val="0"/>
+              </a:ext>
+            </a:extLst>
+          </a:blip>
+          <a:stretch>
+            <a:fillRect/>
+          </a:stretch>
+        </p:blipFill>
+        <p:spPr>
+          <a:xfrm>
+            <a:off x="9169400" y="3429000"/>
+            <a:ext cx="162560" cy="162560"/>
+          </a:xfrm>
+          <a:prstGeom prst="rect">
+            <a:avLst/>
+          </a:prstGeom>
+        </p:spPr>
+      </p:pic>
+    </p:spTree>
+    <p:extLst>
+      <p:ext uri="{BB962C8B-B14F-4D97-AF65-F5344CB8AC3E}">
+        <p14:creationId xmlns:p14="http://schemas.microsoft.com/office/powerpoint/2010/main" val="2616341515"/>
       </p:ext>
     </p:extLst>
   </p:cSld>

</xml_diff>